<commit_message>
mid oss final study
</commit_message>
<xml_diff>
--- a/오픈소스소프트웨어/5주차_리눅스 명령어.pptx
+++ b/오픈소스소프트웨어/5주차_리눅스 명령어.pptx
@@ -2887,6 +2887,13 @@
           </a:solidFill>
           <a:ln/>
         </p:spPr>
+        <p:txBody>
+          <a:bodyPr/>
+          <a:lstStyle/>
+          <a:p>
+            <a:endParaRPr lang="ko-KR" altLang="en-US"/>
+          </a:p>
+        </p:txBody>
       </p:sp>
       <p:sp>
         <p:nvSpPr>
@@ -2907,6 +2914,13 @@
           </a:solidFill>
           <a:ln/>
         </p:spPr>
+        <p:txBody>
+          <a:bodyPr/>
+          <a:lstStyle/>
+          <a:p>
+            <a:endParaRPr lang="ko-KR" altLang="en-US"/>
+          </a:p>
+        </p:txBody>
       </p:sp>
       <p:sp>
         <p:nvSpPr>
@@ -2927,6 +2941,13 @@
           </a:solidFill>
           <a:ln/>
         </p:spPr>
+        <p:txBody>
+          <a:bodyPr/>
+          <a:lstStyle/>
+          <a:p>
+            <a:endParaRPr lang="ko-KR" altLang="en-US"/>
+          </a:p>
+        </p:txBody>
       </p:sp>
       <p:sp>
         <p:nvSpPr>
@@ -2947,6 +2968,13 @@
           </a:solidFill>
           <a:ln/>
         </p:spPr>
+        <p:txBody>
+          <a:bodyPr/>
+          <a:lstStyle/>
+          <a:p>
+            <a:endParaRPr lang="ko-KR" altLang="en-US"/>
+          </a:p>
+        </p:txBody>
       </p:sp>
       <p:sp>
         <p:nvSpPr>
@@ -2967,6 +2995,13 @@
           </a:solidFill>
           <a:ln/>
         </p:spPr>
+        <p:txBody>
+          <a:bodyPr/>
+          <a:lstStyle/>
+          <a:p>
+            <a:endParaRPr lang="ko-KR" altLang="en-US"/>
+          </a:p>
+        </p:txBody>
       </p:sp>
       <p:sp>
         <p:nvSpPr>
@@ -2987,6 +3022,13 @@
           </a:solidFill>
           <a:ln/>
         </p:spPr>
+        <p:txBody>
+          <a:bodyPr/>
+          <a:lstStyle/>
+          <a:p>
+            <a:endParaRPr lang="ko-KR" altLang="en-US"/>
+          </a:p>
+        </p:txBody>
       </p:sp>
       <p:sp>
         <p:nvSpPr>
@@ -3007,6 +3049,13 @@
           </a:solidFill>
           <a:ln/>
         </p:spPr>
+        <p:txBody>
+          <a:bodyPr/>
+          <a:lstStyle/>
+          <a:p>
+            <a:endParaRPr lang="ko-KR" altLang="en-US"/>
+          </a:p>
+        </p:txBody>
       </p:sp>
       <p:sp>
         <p:nvSpPr>
@@ -3027,6 +3076,13 @@
           </a:solidFill>
           <a:ln/>
         </p:spPr>
+        <p:txBody>
+          <a:bodyPr/>
+          <a:lstStyle/>
+          <a:p>
+            <a:endParaRPr lang="ko-KR" altLang="en-US"/>
+          </a:p>
+        </p:txBody>
       </p:sp>
       <p:sp>
         <p:nvSpPr>
@@ -3047,6 +3103,13 @@
           </a:solidFill>
           <a:ln/>
         </p:spPr>
+        <p:txBody>
+          <a:bodyPr/>
+          <a:lstStyle/>
+          <a:p>
+            <a:endParaRPr lang="ko-KR" altLang="en-US"/>
+          </a:p>
+        </p:txBody>
       </p:sp>
       <p:sp>
         <p:nvSpPr>
@@ -3067,6 +3130,13 @@
           </a:solidFill>
           <a:ln/>
         </p:spPr>
+        <p:txBody>
+          <a:bodyPr/>
+          <a:lstStyle/>
+          <a:p>
+            <a:endParaRPr lang="ko-KR" altLang="en-US"/>
+          </a:p>
+        </p:txBody>
       </p:sp>
       <p:sp>
         <p:nvSpPr>
@@ -3087,6 +3157,13 @@
           </a:solidFill>
           <a:ln/>
         </p:spPr>
+        <p:txBody>
+          <a:bodyPr/>
+          <a:lstStyle/>
+          <a:p>
+            <a:endParaRPr lang="ko-KR" altLang="en-US"/>
+          </a:p>
+        </p:txBody>
       </p:sp>
       <p:sp>
         <p:nvSpPr>
@@ -3107,6 +3184,13 @@
           </a:solidFill>
           <a:ln/>
         </p:spPr>
+        <p:txBody>
+          <a:bodyPr/>
+          <a:lstStyle/>
+          <a:p>
+            <a:endParaRPr lang="ko-KR" altLang="en-US"/>
+          </a:p>
+        </p:txBody>
       </p:sp>
       <p:sp>
         <p:nvSpPr>
@@ -3127,6 +3211,13 @@
           </a:solidFill>
           <a:ln/>
         </p:spPr>
+        <p:txBody>
+          <a:bodyPr/>
+          <a:lstStyle/>
+          <a:p>
+            <a:endParaRPr lang="ko-KR" altLang="en-US"/>
+          </a:p>
+        </p:txBody>
       </p:sp>
       <p:sp>
         <p:nvSpPr>
@@ -3147,6 +3238,13 @@
           </a:solidFill>
           <a:ln/>
         </p:spPr>
+        <p:txBody>
+          <a:bodyPr/>
+          <a:lstStyle/>
+          <a:p>
+            <a:endParaRPr lang="ko-KR" altLang="en-US"/>
+          </a:p>
+        </p:txBody>
       </p:sp>
       <p:sp>
         <p:nvSpPr>
@@ -3167,6 +3265,13 @@
           </a:solidFill>
           <a:ln/>
         </p:spPr>
+        <p:txBody>
+          <a:bodyPr/>
+          <a:lstStyle/>
+          <a:p>
+            <a:endParaRPr lang="ko-KR" altLang="en-US"/>
+          </a:p>
+        </p:txBody>
       </p:sp>
       <p:sp>
         <p:nvSpPr>
@@ -3187,6 +3292,13 @@
           </a:solidFill>
           <a:ln/>
         </p:spPr>
+        <p:txBody>
+          <a:bodyPr/>
+          <a:lstStyle/>
+          <a:p>
+            <a:endParaRPr lang="ko-KR" altLang="en-US"/>
+          </a:p>
+        </p:txBody>
       </p:sp>
       <p:sp>
         <p:nvSpPr>
@@ -3207,6 +3319,13 @@
           </a:solidFill>
           <a:ln/>
         </p:spPr>
+        <p:txBody>
+          <a:bodyPr/>
+          <a:lstStyle/>
+          <a:p>
+            <a:endParaRPr lang="ko-KR" altLang="en-US"/>
+          </a:p>
+        </p:txBody>
       </p:sp>
       <p:sp>
         <p:nvSpPr>
@@ -3227,6 +3346,13 @@
           </a:solidFill>
           <a:ln/>
         </p:spPr>
+        <p:txBody>
+          <a:bodyPr/>
+          <a:lstStyle/>
+          <a:p>
+            <a:endParaRPr lang="ko-KR" altLang="en-US"/>
+          </a:p>
+        </p:txBody>
       </p:sp>
       <p:sp>
         <p:nvSpPr>
@@ -3247,6 +3373,13 @@
           </a:solidFill>
           <a:ln/>
         </p:spPr>
+        <p:txBody>
+          <a:bodyPr/>
+          <a:lstStyle/>
+          <a:p>
+            <a:endParaRPr lang="ko-KR" altLang="en-US"/>
+          </a:p>
+        </p:txBody>
       </p:sp>
       <p:sp>
         <p:nvSpPr>
@@ -3267,6 +3400,13 @@
           </a:solidFill>
           <a:ln/>
         </p:spPr>
+        <p:txBody>
+          <a:bodyPr/>
+          <a:lstStyle/>
+          <a:p>
+            <a:endParaRPr lang="ko-KR" altLang="en-US"/>
+          </a:p>
+        </p:txBody>
       </p:sp>
       <p:sp>
         <p:nvSpPr>
@@ -3287,6 +3427,13 @@
           </a:solidFill>
           <a:ln/>
         </p:spPr>
+        <p:txBody>
+          <a:bodyPr/>
+          <a:lstStyle/>
+          <a:p>
+            <a:endParaRPr lang="ko-KR" altLang="en-US"/>
+          </a:p>
+        </p:txBody>
       </p:sp>
       <p:sp>
         <p:nvSpPr>
@@ -3307,6 +3454,13 @@
           </a:solidFill>
           <a:ln/>
         </p:spPr>
+        <p:txBody>
+          <a:bodyPr/>
+          <a:lstStyle/>
+          <a:p>
+            <a:endParaRPr lang="ko-KR" altLang="en-US"/>
+          </a:p>
+        </p:txBody>
       </p:sp>
       <p:sp>
         <p:nvSpPr>
@@ -3327,6 +3481,13 @@
           </a:solidFill>
           <a:ln/>
         </p:spPr>
+        <p:txBody>
+          <a:bodyPr/>
+          <a:lstStyle/>
+          <a:p>
+            <a:endParaRPr lang="ko-KR" altLang="en-US"/>
+          </a:p>
+        </p:txBody>
       </p:sp>
       <p:sp>
         <p:nvSpPr>
@@ -3347,6 +3508,13 @@
           </a:solidFill>
           <a:ln/>
         </p:spPr>
+        <p:txBody>
+          <a:bodyPr/>
+          <a:lstStyle/>
+          <a:p>
+            <a:endParaRPr lang="ko-KR" altLang="en-US"/>
+          </a:p>
+        </p:txBody>
       </p:sp>
       <p:sp>
         <p:nvSpPr>
@@ -3369,6 +3537,13 @@
           </a:solidFill>
           <a:ln/>
         </p:spPr>
+        <p:txBody>
+          <a:bodyPr/>
+          <a:lstStyle/>
+          <a:p>
+            <a:endParaRPr lang="ko-KR" altLang="en-US"/>
+          </a:p>
+        </p:txBody>
       </p:sp>
       <p:sp>
         <p:nvSpPr>
@@ -3619,6 +3794,13 @@
           </a:solidFill>
           <a:ln/>
         </p:spPr>
+        <p:txBody>
+          <a:bodyPr/>
+          <a:lstStyle/>
+          <a:p>
+            <a:endParaRPr lang="ko-KR" altLang="en-US"/>
+          </a:p>
+        </p:txBody>
       </p:sp>
       <p:sp>
         <p:nvSpPr>
@@ -3645,7 +3827,7 @@
               <a:buNone/>
             </a:pPr>
             <a:r>
-              <a:rPr lang="en-US" sz="1300" b="1" dirty="0" smtClean="0">
+              <a:rPr lang="en-US" sz="1300" b="1" dirty="0">
                 <a:solidFill>
                   <a:srgbClr val="1B2028"/>
                 </a:solidFill>
@@ -3804,6 +3986,13 @@
             </a:outerShdw>
           </a:effectLst>
         </p:spPr>
+        <p:txBody>
+          <a:bodyPr/>
+          <a:lstStyle/>
+          <a:p>
+            <a:endParaRPr lang="ko-KR" altLang="en-US"/>
+          </a:p>
+        </p:txBody>
       </p:sp>
       <p:sp>
         <p:nvSpPr>
@@ -3824,6 +4013,13 @@
           </a:solidFill>
           <a:ln/>
         </p:spPr>
+        <p:txBody>
+          <a:bodyPr/>
+          <a:lstStyle/>
+          <a:p>
+            <a:endParaRPr lang="ko-KR" altLang="en-US"/>
+          </a:p>
+        </p:txBody>
       </p:sp>
       <p:sp>
         <p:nvSpPr>
@@ -3844,6 +4040,13 @@
           </a:solidFill>
           <a:ln/>
         </p:spPr>
+        <p:txBody>
+          <a:bodyPr/>
+          <a:lstStyle/>
+          <a:p>
+            <a:endParaRPr lang="ko-KR" altLang="en-US"/>
+          </a:p>
+        </p:txBody>
       </p:sp>
       <p:sp>
         <p:nvSpPr>
@@ -3864,6 +4067,13 @@
           </a:solidFill>
           <a:ln/>
         </p:spPr>
+        <p:txBody>
+          <a:bodyPr/>
+          <a:lstStyle/>
+          <a:p>
+            <a:endParaRPr lang="ko-KR" altLang="en-US"/>
+          </a:p>
+        </p:txBody>
       </p:sp>
       <p:sp>
         <p:nvSpPr>
@@ -4376,6 +4586,13 @@
             </a:outerShdw>
           </a:effectLst>
         </p:spPr>
+        <p:txBody>
+          <a:bodyPr/>
+          <a:lstStyle/>
+          <a:p>
+            <a:endParaRPr lang="ko-KR" altLang="en-US"/>
+          </a:p>
+        </p:txBody>
       </p:sp>
       <p:sp>
         <p:nvSpPr>
@@ -4396,6 +4613,13 @@
           </a:solidFill>
           <a:ln/>
         </p:spPr>
+        <p:txBody>
+          <a:bodyPr/>
+          <a:lstStyle/>
+          <a:p>
+            <a:endParaRPr lang="ko-KR" altLang="en-US"/>
+          </a:p>
+        </p:txBody>
       </p:sp>
       <p:sp>
         <p:nvSpPr>
@@ -4416,6 +4640,13 @@
           </a:solidFill>
           <a:ln/>
         </p:spPr>
+        <p:txBody>
+          <a:bodyPr/>
+          <a:lstStyle/>
+          <a:p>
+            <a:endParaRPr lang="ko-KR" altLang="en-US"/>
+          </a:p>
+        </p:txBody>
       </p:sp>
       <p:sp>
         <p:nvSpPr>
@@ -4436,6 +4667,13 @@
           </a:solidFill>
           <a:ln/>
         </p:spPr>
+        <p:txBody>
+          <a:bodyPr/>
+          <a:lstStyle/>
+          <a:p>
+            <a:endParaRPr lang="ko-KR" altLang="en-US"/>
+          </a:p>
+        </p:txBody>
       </p:sp>
       <p:sp>
         <p:nvSpPr>
@@ -4551,6 +4789,13 @@
             </a:outerShdw>
           </a:effectLst>
         </p:spPr>
+        <p:txBody>
+          <a:bodyPr/>
+          <a:lstStyle/>
+          <a:p>
+            <a:endParaRPr lang="ko-KR" altLang="en-US"/>
+          </a:p>
+        </p:txBody>
       </p:sp>
       <p:sp>
         <p:nvSpPr>
@@ -4607,29 +4852,7 @@
                 <a:ea typeface="Calibri" pitchFamily="34" charset="-122"/>
                 <a:cs typeface="Calibri" pitchFamily="34" charset="-120"/>
               </a:rPr>
-              <a:t> </a:t>
-            </a:r>
-            <a:r>
-              <a:rPr lang="en-US" sz="1400" b="1" dirty="0" smtClean="0">
-                <a:solidFill>
-                  <a:srgbClr val="1B2028"/>
-                </a:solidFill>
-                <a:latin typeface="Calibri" pitchFamily="34" charset="0"/>
-                <a:ea typeface="Calibri" pitchFamily="34" charset="-122"/>
-                <a:cs typeface="Calibri" pitchFamily="34" charset="-120"/>
-              </a:rPr>
-              <a:t>(=soft </a:t>
-            </a:r>
-            <a:r>
-              <a:rPr lang="en-US" sz="1400" b="1" dirty="0">
-                <a:solidFill>
-                  <a:srgbClr val="1B2028"/>
-                </a:solidFill>
-                <a:latin typeface="Calibri" pitchFamily="34" charset="0"/>
-                <a:ea typeface="Calibri" pitchFamily="34" charset="-122"/>
-                <a:cs typeface="Calibri" pitchFamily="34" charset="-120"/>
-              </a:rPr>
-              <a:t>link)</a:t>
+              <a:t> (=soft link)</a:t>
             </a:r>
             <a:endParaRPr lang="en-US" sz="1400" dirty="0"/>
           </a:p>
@@ -4661,6 +4884,13 @@
             <a:prstDash val="solid"/>
           </a:ln>
         </p:spPr>
+        <p:txBody>
+          <a:bodyPr/>
+          <a:lstStyle/>
+          <a:p>
+            <a:endParaRPr lang="ko-KR" altLang="en-US"/>
+          </a:p>
+        </p:txBody>
       </p:sp>
       <p:sp>
         <p:nvSpPr>
@@ -4750,6 +4980,13 @@
             <a:prstDash val="solid"/>
           </a:ln>
         </p:spPr>
+        <p:txBody>
+          <a:bodyPr/>
+          <a:lstStyle/>
+          <a:p>
+            <a:endParaRPr lang="ko-KR" altLang="en-US"/>
+          </a:p>
+        </p:txBody>
       </p:sp>
       <p:sp>
         <p:nvSpPr>
@@ -4813,6 +5050,13 @@
             <a:tailEnd type="triangle"/>
           </a:ln>
         </p:spPr>
+        <p:txBody>
+          <a:bodyPr/>
+          <a:lstStyle/>
+          <a:p>
+            <a:endParaRPr lang="ko-KR" altLang="en-US"/>
+          </a:p>
+        </p:txBody>
       </p:sp>
       <p:sp>
         <p:nvSpPr>
@@ -4840,6 +5084,13 @@
             <a:prstDash val="solid"/>
           </a:ln>
         </p:spPr>
+        <p:txBody>
+          <a:bodyPr/>
+          <a:lstStyle/>
+          <a:p>
+            <a:endParaRPr lang="ko-KR" altLang="en-US"/>
+          </a:p>
+        </p:txBody>
       </p:sp>
       <p:sp>
         <p:nvSpPr>
@@ -4977,18 +5228,7 @@
                 <a:ea typeface="Calibri" pitchFamily="34" charset="-122"/>
                 <a:cs typeface="Calibri" pitchFamily="34" charset="-120"/>
               </a:rPr>
-              <a:t>원본을 삭제하면 경로가 끊어져 symlink가 깨짐 (broken link</a:t>
-            </a:r>
-            <a:r>
-              <a:rPr lang="en-US" sz="1150" dirty="0" smtClean="0">
-                <a:solidFill>
-                  <a:srgbClr val="1B2028"/>
-                </a:solidFill>
-                <a:latin typeface="Calibri" pitchFamily="34" charset="0"/>
-                <a:ea typeface="Calibri" pitchFamily="34" charset="-122"/>
-                <a:cs typeface="Calibri" pitchFamily="34" charset="-120"/>
-              </a:rPr>
-              <a:t>)</a:t>
+              <a:t>원본을 삭제하면 경로가 끊어져 symlink가 깨짐 (broken link)</a:t>
             </a:r>
           </a:p>
           <a:p>
@@ -5155,7 +5395,7 @@
               <a:t> 수 </a:t>
             </a:r>
             <a:r>
-              <a:rPr lang="en-US" altLang="ko-KR" sz="1100" dirty="0" err="1" smtClean="0">
+              <a:rPr lang="en-US" altLang="ko-KR" sz="1100" dirty="0" err="1">
                 <a:solidFill>
                   <a:srgbClr val="1B2028"/>
                 </a:solidFill>
@@ -5202,6 +5442,13 @@
             </a:outerShdw>
           </a:effectLst>
         </p:spPr>
+        <p:txBody>
+          <a:bodyPr/>
+          <a:lstStyle/>
+          <a:p>
+            <a:endParaRPr lang="ko-KR" altLang="en-US"/>
+          </a:p>
+        </p:txBody>
       </p:sp>
       <p:sp>
         <p:nvSpPr>
@@ -5268,6 +5515,13 @@
             <a:prstDash val="solid"/>
           </a:ln>
         </p:spPr>
+        <p:txBody>
+          <a:bodyPr/>
+          <a:lstStyle/>
+          <a:p>
+            <a:endParaRPr lang="ko-KR" altLang="en-US"/>
+          </a:p>
+        </p:txBody>
       </p:sp>
       <p:sp>
         <p:nvSpPr>
@@ -5357,6 +5611,13 @@
             <a:prstDash val="solid"/>
           </a:ln>
         </p:spPr>
+        <p:txBody>
+          <a:bodyPr/>
+          <a:lstStyle/>
+          <a:p>
+            <a:endParaRPr lang="ko-KR" altLang="en-US"/>
+          </a:p>
+        </p:txBody>
       </p:sp>
       <p:sp>
         <p:nvSpPr>
@@ -5420,6 +5681,13 @@
             <a:tailEnd type="triangle"/>
           </a:ln>
         </p:spPr>
+        <p:txBody>
+          <a:bodyPr/>
+          <a:lstStyle/>
+          <a:p>
+            <a:endParaRPr lang="ko-KR" altLang="en-US"/>
+          </a:p>
+        </p:txBody>
       </p:sp>
       <p:sp>
         <p:nvSpPr>
@@ -5447,6 +5715,13 @@
             <a:prstDash val="solid"/>
           </a:ln>
         </p:spPr>
+        <p:txBody>
+          <a:bodyPr/>
+          <a:lstStyle/>
+          <a:p>
+            <a:endParaRPr lang="ko-KR" altLang="en-US"/>
+          </a:p>
+        </p:txBody>
       </p:sp>
       <p:sp>
         <p:nvSpPr>
@@ -5533,6 +5808,13 @@
             <a:tailEnd type="triangle"/>
           </a:ln>
         </p:spPr>
+        <p:txBody>
+          <a:bodyPr/>
+          <a:lstStyle/>
+          <a:p>
+            <a:endParaRPr lang="ko-KR" altLang="en-US"/>
+          </a:p>
+        </p:txBody>
       </p:sp>
       <p:sp>
         <p:nvSpPr>
@@ -5656,7 +5938,7 @@
               <a:t> </a:t>
             </a:r>
             <a:r>
-              <a:rPr lang="en-US" sz="1150" dirty="0" err="1" smtClean="0">
+              <a:rPr lang="en-US" sz="1150" dirty="0" err="1">
                 <a:solidFill>
                   <a:srgbClr val="1B2028"/>
                 </a:solidFill>
@@ -5666,7 +5948,7 @@
               </a:rPr>
               <a:t>유지됨</a:t>
             </a:r>
-            <a:endParaRPr lang="en-US" sz="1150" dirty="0" smtClean="0">
+            <a:endParaRPr lang="en-US" sz="1150" dirty="0">
               <a:solidFill>
                 <a:srgbClr val="1B2028"/>
               </a:solidFill>
@@ -5872,6 +6154,13 @@
             <a:schemeClr val="tx1"/>
           </a:fontRef>
         </p:style>
+        <p:txBody>
+          <a:bodyPr/>
+          <a:lstStyle/>
+          <a:p>
+            <a:endParaRPr lang="ko-KR" altLang="en-US"/>
+          </a:p>
+        </p:txBody>
       </p:sp>
     </p:spTree>
     <p:extLst>
@@ -6056,6 +6345,13 @@
             </a:outerShdw>
           </a:effectLst>
         </p:spPr>
+        <p:txBody>
+          <a:bodyPr/>
+          <a:lstStyle/>
+          <a:p>
+            <a:endParaRPr lang="ko-KR" altLang="en-US"/>
+          </a:p>
+        </p:txBody>
       </p:sp>
       <p:sp>
         <p:nvSpPr>
@@ -6076,6 +6372,13 @@
           </a:solidFill>
           <a:ln/>
         </p:spPr>
+        <p:txBody>
+          <a:bodyPr/>
+          <a:lstStyle/>
+          <a:p>
+            <a:endParaRPr lang="ko-KR" altLang="en-US"/>
+          </a:p>
+        </p:txBody>
       </p:sp>
       <p:sp>
         <p:nvSpPr>
@@ -6096,6 +6399,13 @@
           </a:solidFill>
           <a:ln/>
         </p:spPr>
+        <p:txBody>
+          <a:bodyPr/>
+          <a:lstStyle/>
+          <a:p>
+            <a:endParaRPr lang="ko-KR" altLang="en-US"/>
+          </a:p>
+        </p:txBody>
       </p:sp>
       <p:sp>
         <p:nvSpPr>
@@ -6116,6 +6426,13 @@
           </a:solidFill>
           <a:ln/>
         </p:spPr>
+        <p:txBody>
+          <a:bodyPr/>
+          <a:lstStyle/>
+          <a:p>
+            <a:endParaRPr lang="ko-KR" altLang="en-US"/>
+          </a:p>
+        </p:txBody>
       </p:sp>
       <p:sp>
         <p:nvSpPr>
@@ -6432,6 +6749,13 @@
           </a:solidFill>
           <a:ln/>
         </p:spPr>
+        <p:txBody>
+          <a:bodyPr/>
+          <a:lstStyle/>
+          <a:p>
+            <a:endParaRPr lang="ko-KR" altLang="en-US"/>
+          </a:p>
+        </p:txBody>
       </p:sp>
       <p:sp>
         <p:nvSpPr>
@@ -6458,7 +6782,7 @@
               <a:buNone/>
             </a:pPr>
             <a:r>
-              <a:rPr lang="en-US" sz="1300" b="1" dirty="0" smtClean="0">
+              <a:rPr lang="en-US" sz="1300" b="1" dirty="0">
                 <a:solidFill>
                   <a:srgbClr val="1B2028"/>
                 </a:solidFill>
@@ -6617,6 +6941,13 @@
             </a:outerShdw>
           </a:effectLst>
         </p:spPr>
+        <p:txBody>
+          <a:bodyPr/>
+          <a:lstStyle/>
+          <a:p>
+            <a:endParaRPr lang="ko-KR" altLang="en-US"/>
+          </a:p>
+        </p:txBody>
       </p:sp>
       <p:sp>
         <p:nvSpPr>
@@ -6637,6 +6968,13 @@
           </a:solidFill>
           <a:ln/>
         </p:spPr>
+        <p:txBody>
+          <a:bodyPr/>
+          <a:lstStyle/>
+          <a:p>
+            <a:endParaRPr lang="ko-KR" altLang="en-US"/>
+          </a:p>
+        </p:txBody>
       </p:sp>
       <p:sp>
         <p:nvSpPr>
@@ -6657,6 +6995,13 @@
           </a:solidFill>
           <a:ln/>
         </p:spPr>
+        <p:txBody>
+          <a:bodyPr/>
+          <a:lstStyle/>
+          <a:p>
+            <a:endParaRPr lang="ko-KR" altLang="en-US"/>
+          </a:p>
+        </p:txBody>
       </p:sp>
       <p:sp>
         <p:nvSpPr>
@@ -6677,6 +7022,13 @@
           </a:solidFill>
           <a:ln/>
         </p:spPr>
+        <p:txBody>
+          <a:bodyPr/>
+          <a:lstStyle/>
+          <a:p>
+            <a:endParaRPr lang="ko-KR" altLang="en-US"/>
+          </a:p>
+        </p:txBody>
       </p:sp>
       <p:sp>
         <p:nvSpPr>
@@ -6840,6 +7192,13 @@
           </a:solidFill>
           <a:ln/>
         </p:spPr>
+        <p:txBody>
+          <a:bodyPr/>
+          <a:lstStyle/>
+          <a:p>
+            <a:endParaRPr lang="ko-KR" altLang="en-US"/>
+          </a:p>
+        </p:txBody>
       </p:sp>
       <p:sp>
         <p:nvSpPr>
@@ -6860,6 +7219,13 @@
           </a:solidFill>
           <a:ln/>
         </p:spPr>
+        <p:txBody>
+          <a:bodyPr/>
+          <a:lstStyle/>
+          <a:p>
+            <a:endParaRPr lang="ko-KR" altLang="en-US"/>
+          </a:p>
+        </p:txBody>
       </p:sp>
       <p:sp>
         <p:nvSpPr>
@@ -7129,6 +7495,13 @@
             <a:prstDash val="solid"/>
           </a:ln>
         </p:spPr>
+        <p:txBody>
+          <a:bodyPr/>
+          <a:lstStyle/>
+          <a:p>
+            <a:endParaRPr lang="ko-KR" altLang="en-US"/>
+          </a:p>
+        </p:txBody>
       </p:sp>
       <p:sp>
         <p:nvSpPr>
@@ -7195,6 +7568,13 @@
             <a:prstDash val="solid"/>
           </a:ln>
         </p:spPr>
+        <p:txBody>
+          <a:bodyPr/>
+          <a:lstStyle/>
+          <a:p>
+            <a:endParaRPr lang="ko-KR" altLang="en-US"/>
+          </a:p>
+        </p:txBody>
       </p:sp>
       <p:sp>
         <p:nvSpPr>
@@ -7300,6 +7680,13 @@
             <a:prstDash val="solid"/>
           </a:ln>
         </p:spPr>
+        <p:txBody>
+          <a:bodyPr/>
+          <a:lstStyle/>
+          <a:p>
+            <a:endParaRPr lang="ko-KR" altLang="en-US"/>
+          </a:p>
+        </p:txBody>
       </p:sp>
       <p:sp>
         <p:nvSpPr>
@@ -7405,6 +7792,13 @@
             <a:prstDash val="solid"/>
           </a:ln>
         </p:spPr>
+        <p:txBody>
+          <a:bodyPr/>
+          <a:lstStyle/>
+          <a:p>
+            <a:endParaRPr lang="ko-KR" altLang="en-US"/>
+          </a:p>
+        </p:txBody>
       </p:sp>
       <p:sp>
         <p:nvSpPr>
@@ -7510,6 +7904,13 @@
             <a:prstDash val="solid"/>
           </a:ln>
         </p:spPr>
+        <p:txBody>
+          <a:bodyPr/>
+          <a:lstStyle/>
+          <a:p>
+            <a:endParaRPr lang="ko-KR" altLang="en-US"/>
+          </a:p>
+        </p:txBody>
       </p:sp>
       <p:sp>
         <p:nvSpPr>
@@ -7576,6 +7977,13 @@
             <a:prstDash val="solid"/>
           </a:ln>
         </p:spPr>
+        <p:txBody>
+          <a:bodyPr/>
+          <a:lstStyle/>
+          <a:p>
+            <a:endParaRPr lang="ko-KR" altLang="en-US"/>
+          </a:p>
+        </p:txBody>
       </p:sp>
       <p:sp>
         <p:nvSpPr>
@@ -7681,6 +8089,13 @@
             <a:prstDash val="solid"/>
           </a:ln>
         </p:spPr>
+        <p:txBody>
+          <a:bodyPr/>
+          <a:lstStyle/>
+          <a:p>
+            <a:endParaRPr lang="ko-KR" altLang="en-US"/>
+          </a:p>
+        </p:txBody>
       </p:sp>
       <p:sp>
         <p:nvSpPr>
@@ -7786,6 +8201,13 @@
             <a:prstDash val="solid"/>
           </a:ln>
         </p:spPr>
+        <p:txBody>
+          <a:bodyPr/>
+          <a:lstStyle/>
+          <a:p>
+            <a:endParaRPr lang="ko-KR" altLang="en-US"/>
+          </a:p>
+        </p:txBody>
       </p:sp>
       <p:sp>
         <p:nvSpPr>
@@ -7891,6 +8313,13 @@
             <a:prstDash val="solid"/>
           </a:ln>
         </p:spPr>
+        <p:txBody>
+          <a:bodyPr/>
+          <a:lstStyle/>
+          <a:p>
+            <a:endParaRPr lang="ko-KR" altLang="en-US"/>
+          </a:p>
+        </p:txBody>
       </p:sp>
       <p:sp>
         <p:nvSpPr>
@@ -7957,6 +8386,13 @@
             <a:prstDash val="solid"/>
           </a:ln>
         </p:spPr>
+        <p:txBody>
+          <a:bodyPr/>
+          <a:lstStyle/>
+          <a:p>
+            <a:endParaRPr lang="ko-KR" altLang="en-US"/>
+          </a:p>
+        </p:txBody>
       </p:sp>
       <p:sp>
         <p:nvSpPr>
@@ -8062,6 +8498,13 @@
             <a:prstDash val="solid"/>
           </a:ln>
         </p:spPr>
+        <p:txBody>
+          <a:bodyPr/>
+          <a:lstStyle/>
+          <a:p>
+            <a:endParaRPr lang="ko-KR" altLang="en-US"/>
+          </a:p>
+        </p:txBody>
       </p:sp>
       <p:sp>
         <p:nvSpPr>
@@ -8167,6 +8610,13 @@
             <a:prstDash val="solid"/>
           </a:ln>
         </p:spPr>
+        <p:txBody>
+          <a:bodyPr/>
+          <a:lstStyle/>
+          <a:p>
+            <a:endParaRPr lang="ko-KR" altLang="en-US"/>
+          </a:p>
+        </p:txBody>
       </p:sp>
       <p:sp>
         <p:nvSpPr>
@@ -8575,6 +9025,13 @@
           </a:solidFill>
           <a:ln/>
         </p:spPr>
+        <p:txBody>
+          <a:bodyPr/>
+          <a:lstStyle/>
+          <a:p>
+            <a:endParaRPr lang="ko-KR" altLang="en-US"/>
+          </a:p>
+        </p:txBody>
       </p:sp>
       <p:sp>
         <p:nvSpPr>
@@ -8595,6 +9052,13 @@
           </a:solidFill>
           <a:ln/>
         </p:spPr>
+        <p:txBody>
+          <a:bodyPr/>
+          <a:lstStyle/>
+          <a:p>
+            <a:endParaRPr lang="ko-KR" altLang="en-US"/>
+          </a:p>
+        </p:txBody>
       </p:sp>
       <p:sp>
         <p:nvSpPr>
@@ -8866,6 +9330,13 @@
             </a:outerShdw>
           </a:effectLst>
         </p:spPr>
+        <p:txBody>
+          <a:bodyPr/>
+          <a:lstStyle/>
+          <a:p>
+            <a:endParaRPr lang="ko-KR" altLang="en-US"/>
+          </a:p>
+        </p:txBody>
       </p:sp>
       <p:sp>
         <p:nvSpPr>
@@ -8886,6 +9357,13 @@
           </a:solidFill>
           <a:ln/>
         </p:spPr>
+        <p:txBody>
+          <a:bodyPr/>
+          <a:lstStyle/>
+          <a:p>
+            <a:endParaRPr lang="ko-KR" altLang="en-US"/>
+          </a:p>
+        </p:txBody>
       </p:sp>
       <p:sp>
         <p:nvSpPr>
@@ -8906,6 +9384,13 @@
           </a:solidFill>
           <a:ln/>
         </p:spPr>
+        <p:txBody>
+          <a:bodyPr/>
+          <a:lstStyle/>
+          <a:p>
+            <a:endParaRPr lang="ko-KR" altLang="en-US"/>
+          </a:p>
+        </p:txBody>
       </p:sp>
       <p:sp>
         <p:nvSpPr>
@@ -8926,6 +9411,13 @@
           </a:solidFill>
           <a:ln/>
         </p:spPr>
+        <p:txBody>
+          <a:bodyPr/>
+          <a:lstStyle/>
+          <a:p>
+            <a:endParaRPr lang="ko-KR" altLang="en-US"/>
+          </a:p>
+        </p:txBody>
       </p:sp>
       <p:sp>
         <p:nvSpPr>
@@ -9105,6 +9597,13 @@
             </a:outerShdw>
           </a:effectLst>
         </p:spPr>
+        <p:txBody>
+          <a:bodyPr/>
+          <a:lstStyle/>
+          <a:p>
+            <a:endParaRPr lang="ko-KR" altLang="en-US"/>
+          </a:p>
+        </p:txBody>
       </p:sp>
       <p:sp>
         <p:nvSpPr>
@@ -9125,6 +9624,13 @@
           </a:solidFill>
           <a:ln/>
         </p:spPr>
+        <p:txBody>
+          <a:bodyPr/>
+          <a:lstStyle/>
+          <a:p>
+            <a:endParaRPr lang="ko-KR" altLang="en-US"/>
+          </a:p>
+        </p:txBody>
       </p:sp>
       <p:sp>
         <p:nvSpPr>
@@ -9145,6 +9651,13 @@
           </a:solidFill>
           <a:ln/>
         </p:spPr>
+        <p:txBody>
+          <a:bodyPr/>
+          <a:lstStyle/>
+          <a:p>
+            <a:endParaRPr lang="ko-KR" altLang="en-US"/>
+          </a:p>
+        </p:txBody>
       </p:sp>
       <p:sp>
         <p:nvSpPr>
@@ -9165,6 +9678,13 @@
           </a:solidFill>
           <a:ln/>
         </p:spPr>
+        <p:txBody>
+          <a:bodyPr/>
+          <a:lstStyle/>
+          <a:p>
+            <a:endParaRPr lang="ko-KR" altLang="en-US"/>
+          </a:p>
+        </p:txBody>
       </p:sp>
       <p:sp>
         <p:nvSpPr>
@@ -9300,6 +9820,13 @@
             </a:outerShdw>
           </a:effectLst>
         </p:spPr>
+        <p:txBody>
+          <a:bodyPr/>
+          <a:lstStyle/>
+          <a:p>
+            <a:endParaRPr lang="ko-KR" altLang="en-US"/>
+          </a:p>
+        </p:txBody>
       </p:sp>
       <p:sp>
         <p:nvSpPr>
@@ -9438,6 +9965,13 @@
             <a:prstDash val="solid"/>
           </a:ln>
         </p:spPr>
+        <p:txBody>
+          <a:bodyPr/>
+          <a:lstStyle/>
+          <a:p>
+            <a:endParaRPr lang="ko-KR" altLang="en-US"/>
+          </a:p>
+        </p:txBody>
       </p:sp>
       <p:sp>
         <p:nvSpPr>
@@ -9543,6 +10077,13 @@
             <a:prstDash val="solid"/>
           </a:ln>
         </p:spPr>
+        <p:txBody>
+          <a:bodyPr/>
+          <a:lstStyle/>
+          <a:p>
+            <a:endParaRPr lang="ko-KR" altLang="en-US"/>
+          </a:p>
+        </p:txBody>
       </p:sp>
       <p:sp>
         <p:nvSpPr>
@@ -9648,6 +10189,13 @@
             <a:prstDash val="solid"/>
           </a:ln>
         </p:spPr>
+        <p:txBody>
+          <a:bodyPr/>
+          <a:lstStyle/>
+          <a:p>
+            <a:endParaRPr lang="ko-KR" altLang="en-US"/>
+          </a:p>
+        </p:txBody>
       </p:sp>
       <p:sp>
         <p:nvSpPr>
@@ -9757,6 +10305,13 @@
             <a:prstDash val="solid"/>
           </a:ln>
         </p:spPr>
+        <p:txBody>
+          <a:bodyPr/>
+          <a:lstStyle/>
+          <a:p>
+            <a:endParaRPr lang="ko-KR" altLang="en-US"/>
+          </a:p>
+        </p:txBody>
       </p:sp>
       <p:sp>
         <p:nvSpPr>
@@ -9862,6 +10417,13 @@
             <a:prstDash val="solid"/>
           </a:ln>
         </p:spPr>
+        <p:txBody>
+          <a:bodyPr/>
+          <a:lstStyle/>
+          <a:p>
+            <a:endParaRPr lang="ko-KR" altLang="en-US"/>
+          </a:p>
+        </p:txBody>
       </p:sp>
       <p:sp>
         <p:nvSpPr>
@@ -9971,6 +10533,13 @@
             <a:prstDash val="solid"/>
           </a:ln>
         </p:spPr>
+        <p:txBody>
+          <a:bodyPr/>
+          <a:lstStyle/>
+          <a:p>
+            <a:endParaRPr lang="ko-KR" altLang="en-US"/>
+          </a:p>
+        </p:txBody>
       </p:sp>
       <p:sp>
         <p:nvSpPr>
@@ -10228,6 +10797,13 @@
             </a:outerShdw>
           </a:effectLst>
         </p:spPr>
+        <p:txBody>
+          <a:bodyPr/>
+          <a:lstStyle/>
+          <a:p>
+            <a:endParaRPr lang="ko-KR" altLang="en-US"/>
+          </a:p>
+        </p:txBody>
       </p:sp>
       <p:sp>
         <p:nvSpPr>
@@ -10248,6 +10824,13 @@
           </a:solidFill>
           <a:ln/>
         </p:spPr>
+        <p:txBody>
+          <a:bodyPr/>
+          <a:lstStyle/>
+          <a:p>
+            <a:endParaRPr lang="ko-KR" altLang="en-US"/>
+          </a:p>
+        </p:txBody>
       </p:sp>
       <p:sp>
         <p:nvSpPr>
@@ -10268,6 +10851,13 @@
           </a:solidFill>
           <a:ln/>
         </p:spPr>
+        <p:txBody>
+          <a:bodyPr/>
+          <a:lstStyle/>
+          <a:p>
+            <a:endParaRPr lang="ko-KR" altLang="en-US"/>
+          </a:p>
+        </p:txBody>
       </p:sp>
       <p:sp>
         <p:nvSpPr>
@@ -10288,6 +10878,13 @@
           </a:solidFill>
           <a:ln/>
         </p:spPr>
+        <p:txBody>
+          <a:bodyPr/>
+          <a:lstStyle/>
+          <a:p>
+            <a:endParaRPr lang="ko-KR" altLang="en-US"/>
+          </a:p>
+        </p:txBody>
       </p:sp>
       <p:sp>
         <p:nvSpPr>
@@ -10509,6 +11106,13 @@
           </a:solidFill>
           <a:ln/>
         </p:spPr>
+        <p:txBody>
+          <a:bodyPr/>
+          <a:lstStyle/>
+          <a:p>
+            <a:endParaRPr lang="ko-KR" altLang="en-US"/>
+          </a:p>
+        </p:txBody>
       </p:sp>
       <p:sp>
         <p:nvSpPr>
@@ -10529,6 +11133,13 @@
           </a:solidFill>
           <a:ln/>
         </p:spPr>
+        <p:txBody>
+          <a:bodyPr/>
+          <a:lstStyle/>
+          <a:p>
+            <a:endParaRPr lang="ko-KR" altLang="en-US"/>
+          </a:p>
+        </p:txBody>
       </p:sp>
       <p:sp>
         <p:nvSpPr>
@@ -10629,6 +11240,13 @@
           </a:solidFill>
           <a:ln/>
         </p:spPr>
+        <p:txBody>
+          <a:bodyPr/>
+          <a:lstStyle/>
+          <a:p>
+            <a:endParaRPr lang="ko-KR" altLang="en-US"/>
+          </a:p>
+        </p:txBody>
       </p:sp>
       <p:sp>
         <p:nvSpPr>
@@ -10655,7 +11273,7 @@
               <a:buNone/>
             </a:pPr>
             <a:r>
-              <a:rPr lang="en-US" sz="1300" b="1" dirty="0" smtClean="0">
+              <a:rPr lang="en-US" sz="1300" b="1" dirty="0">
                 <a:solidFill>
                   <a:srgbClr val="1B2028"/>
                 </a:solidFill>
@@ -10853,6 +11471,13 @@
             </a:outerShdw>
           </a:effectLst>
         </p:spPr>
+        <p:txBody>
+          <a:bodyPr/>
+          <a:lstStyle/>
+          <a:p>
+            <a:endParaRPr lang="ko-KR" altLang="en-US"/>
+          </a:p>
+        </p:txBody>
       </p:sp>
       <p:sp>
         <p:nvSpPr>
@@ -10873,6 +11498,13 @@
           </a:solidFill>
           <a:ln/>
         </p:spPr>
+        <p:txBody>
+          <a:bodyPr/>
+          <a:lstStyle/>
+          <a:p>
+            <a:endParaRPr lang="ko-KR" altLang="en-US"/>
+          </a:p>
+        </p:txBody>
       </p:sp>
       <p:sp>
         <p:nvSpPr>
@@ -10893,6 +11525,13 @@
           </a:solidFill>
           <a:ln/>
         </p:spPr>
+        <p:txBody>
+          <a:bodyPr/>
+          <a:lstStyle/>
+          <a:p>
+            <a:endParaRPr lang="ko-KR" altLang="en-US"/>
+          </a:p>
+        </p:txBody>
       </p:sp>
       <p:sp>
         <p:nvSpPr>
@@ -10913,6 +11552,13 @@
           </a:solidFill>
           <a:ln/>
         </p:spPr>
+        <p:txBody>
+          <a:bodyPr/>
+          <a:lstStyle/>
+          <a:p>
+            <a:endParaRPr lang="ko-KR" altLang="en-US"/>
+          </a:p>
+        </p:txBody>
       </p:sp>
       <p:sp>
         <p:nvSpPr>
@@ -11137,6 +11783,13 @@
             <a:prstDash val="solid"/>
           </a:ln>
         </p:spPr>
+        <p:txBody>
+          <a:bodyPr/>
+          <a:lstStyle/>
+          <a:p>
+            <a:endParaRPr lang="ko-KR" altLang="en-US"/>
+          </a:p>
+        </p:txBody>
       </p:sp>
       <p:sp>
         <p:nvSpPr>
@@ -11201,6 +11854,13 @@
             <a:prstDash val="solid"/>
           </a:ln>
         </p:spPr>
+        <p:txBody>
+          <a:bodyPr/>
+          <a:lstStyle/>
+          <a:p>
+            <a:endParaRPr lang="ko-KR" altLang="en-US"/>
+          </a:p>
+        </p:txBody>
       </p:sp>
       <p:sp>
         <p:nvSpPr>
@@ -11265,6 +11925,13 @@
             <a:prstDash val="solid"/>
           </a:ln>
         </p:spPr>
+        <p:txBody>
+          <a:bodyPr/>
+          <a:lstStyle/>
+          <a:p>
+            <a:endParaRPr lang="ko-KR" altLang="en-US"/>
+          </a:p>
+        </p:txBody>
       </p:sp>
       <p:sp>
         <p:nvSpPr>
@@ -11486,6 +12153,13 @@
             <a:prstDash val="solid"/>
           </a:ln>
         </p:spPr>
+        <p:txBody>
+          <a:bodyPr/>
+          <a:lstStyle/>
+          <a:p>
+            <a:endParaRPr lang="ko-KR" altLang="en-US"/>
+          </a:p>
+        </p:txBody>
       </p:sp>
       <p:sp>
         <p:nvSpPr>
@@ -11534,7 +12208,7 @@
               <a:t>— </a:t>
             </a:r>
             <a:r>
-              <a:rPr lang="ko-KR" altLang="en-US" sz="1350" dirty="0" smtClean="0">
+              <a:rPr lang="ko-KR" altLang="en-US" sz="1350" dirty="0">
                 <a:solidFill>
                   <a:srgbClr val="1B2028"/>
                 </a:solidFill>
@@ -11545,7 +12219,7 @@
               <a:t>파일에서 </a:t>
             </a:r>
             <a:r>
-              <a:rPr lang="en-US" sz="1350" dirty="0" err="1" smtClean="0">
+              <a:rPr lang="en-US" sz="1350" dirty="0" err="1">
                 <a:solidFill>
                   <a:srgbClr val="1B2028"/>
                 </a:solidFill>
@@ -11556,7 +12230,7 @@
               <a:t>특정</a:t>
             </a:r>
             <a:r>
-              <a:rPr lang="en-US" sz="1350" dirty="0" smtClean="0">
+              <a:rPr lang="en-US" sz="1350" dirty="0">
                 <a:solidFill>
                   <a:srgbClr val="1B2028"/>
                 </a:solidFill>
@@ -11564,18 +12238,7 @@
                 <a:ea typeface="Calibri" pitchFamily="34" charset="-122"/>
                 <a:cs typeface="Calibri" pitchFamily="34" charset="-120"/>
               </a:rPr>
-              <a:t> </a:t>
-            </a:r>
-            <a:r>
-              <a:rPr lang="en-US" sz="1350" dirty="0">
-                <a:solidFill>
-                  <a:srgbClr val="1B2028"/>
-                </a:solidFill>
-                <a:latin typeface="Calibri" pitchFamily="34" charset="0"/>
-                <a:ea typeface="Calibri" pitchFamily="34" charset="-122"/>
-                <a:cs typeface="Calibri" pitchFamily="34" charset="-120"/>
-              </a:rPr>
-              <a:t>패턴이 포함된 줄을 찾아 출력</a:t>
+              <a:t> 패턴이 포함된 줄을 찾아 출력</a:t>
             </a:r>
             <a:endParaRPr lang="en-US" sz="1600" dirty="0"/>
           </a:p>
@@ -11609,6 +12272,13 @@
             </a:outerShdw>
           </a:effectLst>
         </p:spPr>
+        <p:txBody>
+          <a:bodyPr/>
+          <a:lstStyle/>
+          <a:p>
+            <a:endParaRPr lang="ko-KR" altLang="en-US"/>
+          </a:p>
+        </p:txBody>
       </p:sp>
       <p:sp>
         <p:nvSpPr>
@@ -11629,6 +12299,13 @@
           </a:solidFill>
           <a:ln/>
         </p:spPr>
+        <p:txBody>
+          <a:bodyPr/>
+          <a:lstStyle/>
+          <a:p>
+            <a:endParaRPr lang="ko-KR" altLang="en-US"/>
+          </a:p>
+        </p:txBody>
       </p:sp>
       <p:sp>
         <p:nvSpPr>
@@ -11649,6 +12326,13 @@
           </a:solidFill>
           <a:ln/>
         </p:spPr>
+        <p:txBody>
+          <a:bodyPr/>
+          <a:lstStyle/>
+          <a:p>
+            <a:endParaRPr lang="ko-KR" altLang="en-US"/>
+          </a:p>
+        </p:txBody>
       </p:sp>
       <p:sp>
         <p:nvSpPr>
@@ -11669,6 +12353,13 @@
           </a:solidFill>
           <a:ln/>
         </p:spPr>
+        <p:txBody>
+          <a:bodyPr/>
+          <a:lstStyle/>
+          <a:p>
+            <a:endParaRPr lang="ko-KR" altLang="en-US"/>
+          </a:p>
+        </p:txBody>
       </p:sp>
       <p:sp>
         <p:nvSpPr>
@@ -11989,6 +12680,13 @@
             </a:outerShdw>
           </a:effectLst>
         </p:spPr>
+        <p:txBody>
+          <a:bodyPr/>
+          <a:lstStyle/>
+          <a:p>
+            <a:endParaRPr lang="ko-KR" altLang="en-US"/>
+          </a:p>
+        </p:txBody>
       </p:sp>
       <p:sp>
         <p:nvSpPr>
@@ -12009,6 +12707,13 @@
           </a:solidFill>
           <a:ln/>
         </p:spPr>
+        <p:txBody>
+          <a:bodyPr/>
+          <a:lstStyle/>
+          <a:p>
+            <a:endParaRPr lang="ko-KR" altLang="en-US"/>
+          </a:p>
+        </p:txBody>
       </p:sp>
       <p:sp>
         <p:nvSpPr>
@@ -12029,6 +12734,13 @@
           </a:solidFill>
           <a:ln/>
         </p:spPr>
+        <p:txBody>
+          <a:bodyPr/>
+          <a:lstStyle/>
+          <a:p>
+            <a:endParaRPr lang="ko-KR" altLang="en-US"/>
+          </a:p>
+        </p:txBody>
       </p:sp>
       <p:sp>
         <p:nvSpPr>
@@ -12049,6 +12761,13 @@
           </a:solidFill>
           <a:ln/>
         </p:spPr>
+        <p:txBody>
+          <a:bodyPr/>
+          <a:lstStyle/>
+          <a:p>
+            <a:endParaRPr lang="ko-KR" altLang="en-US"/>
+          </a:p>
+        </p:txBody>
       </p:sp>
       <p:sp>
         <p:nvSpPr>
@@ -12325,6 +13044,13 @@
           </a:solidFill>
           <a:ln/>
         </p:spPr>
+        <p:txBody>
+          <a:bodyPr/>
+          <a:lstStyle/>
+          <a:p>
+            <a:endParaRPr lang="ko-KR" altLang="en-US"/>
+          </a:p>
+        </p:txBody>
       </p:sp>
       <p:sp>
         <p:nvSpPr>
@@ -12351,7 +13077,7 @@
               <a:buNone/>
             </a:pPr>
             <a:r>
-              <a:rPr lang="en-US" sz="1300" b="1" dirty="0" smtClean="0">
+              <a:rPr lang="en-US" sz="1300" b="1" dirty="0">
                 <a:solidFill>
                   <a:srgbClr val="1B2028"/>
                 </a:solidFill>
@@ -12549,6 +13275,13 @@
             </a:outerShdw>
           </a:effectLst>
         </p:spPr>
+        <p:txBody>
+          <a:bodyPr/>
+          <a:lstStyle/>
+          <a:p>
+            <a:endParaRPr lang="ko-KR" altLang="en-US"/>
+          </a:p>
+        </p:txBody>
       </p:sp>
       <p:sp>
         <p:nvSpPr>
@@ -12569,6 +13302,13 @@
           </a:solidFill>
           <a:ln/>
         </p:spPr>
+        <p:txBody>
+          <a:bodyPr/>
+          <a:lstStyle/>
+          <a:p>
+            <a:endParaRPr lang="ko-KR" altLang="en-US"/>
+          </a:p>
+        </p:txBody>
       </p:sp>
       <p:sp>
         <p:nvSpPr>
@@ -12589,6 +13329,13 @@
           </a:solidFill>
           <a:ln/>
         </p:spPr>
+        <p:txBody>
+          <a:bodyPr/>
+          <a:lstStyle/>
+          <a:p>
+            <a:endParaRPr lang="ko-KR" altLang="en-US"/>
+          </a:p>
+        </p:txBody>
       </p:sp>
       <p:sp>
         <p:nvSpPr>
@@ -12609,6 +13356,13 @@
           </a:solidFill>
           <a:ln/>
         </p:spPr>
+        <p:txBody>
+          <a:bodyPr/>
+          <a:lstStyle/>
+          <a:p>
+            <a:endParaRPr lang="ko-KR" altLang="en-US"/>
+          </a:p>
+        </p:txBody>
       </p:sp>
       <p:sp>
         <p:nvSpPr>
@@ -12685,6 +13439,13 @@
             </a:outerShdw>
           </a:effectLst>
         </p:spPr>
+        <p:txBody>
+          <a:bodyPr/>
+          <a:lstStyle/>
+          <a:p>
+            <a:endParaRPr lang="ko-KR" altLang="en-US"/>
+          </a:p>
+        </p:txBody>
       </p:sp>
       <p:sp>
         <p:nvSpPr>
@@ -12705,6 +13466,13 @@
           </a:solidFill>
           <a:ln/>
         </p:spPr>
+        <p:txBody>
+          <a:bodyPr/>
+          <a:lstStyle/>
+          <a:p>
+            <a:endParaRPr lang="ko-KR" altLang="en-US"/>
+          </a:p>
+        </p:txBody>
       </p:sp>
       <p:sp>
         <p:nvSpPr>
@@ -12859,6 +13627,13 @@
             </a:outerShdw>
           </a:effectLst>
         </p:spPr>
+        <p:txBody>
+          <a:bodyPr/>
+          <a:lstStyle/>
+          <a:p>
+            <a:endParaRPr lang="ko-KR" altLang="en-US"/>
+          </a:p>
+        </p:txBody>
       </p:sp>
       <p:sp>
         <p:nvSpPr>
@@ -12879,6 +13654,13 @@
           </a:solidFill>
           <a:ln/>
         </p:spPr>
+        <p:txBody>
+          <a:bodyPr/>
+          <a:lstStyle/>
+          <a:p>
+            <a:endParaRPr lang="ko-KR" altLang="en-US"/>
+          </a:p>
+        </p:txBody>
       </p:sp>
       <p:sp>
         <p:nvSpPr>
@@ -13055,6 +13837,13 @@
             </a:outerShdw>
           </a:effectLst>
         </p:spPr>
+        <p:txBody>
+          <a:bodyPr/>
+          <a:lstStyle/>
+          <a:p>
+            <a:endParaRPr lang="ko-KR" altLang="en-US"/>
+          </a:p>
+        </p:txBody>
       </p:sp>
       <p:sp>
         <p:nvSpPr>
@@ -13075,6 +13864,13 @@
           </a:solidFill>
           <a:ln/>
         </p:spPr>
+        <p:txBody>
+          <a:bodyPr/>
+          <a:lstStyle/>
+          <a:p>
+            <a:endParaRPr lang="ko-KR" altLang="en-US"/>
+          </a:p>
+        </p:txBody>
       </p:sp>
       <p:sp>
         <p:nvSpPr>
@@ -13374,6 +14170,13 @@
             </a:outerShdw>
           </a:effectLst>
         </p:spPr>
+        <p:txBody>
+          <a:bodyPr/>
+          <a:lstStyle/>
+          <a:p>
+            <a:endParaRPr lang="ko-KR" altLang="en-US"/>
+          </a:p>
+        </p:txBody>
       </p:sp>
       <p:sp>
         <p:nvSpPr>
@@ -13394,6 +14197,13 @@
           </a:solidFill>
           <a:ln/>
         </p:spPr>
+        <p:txBody>
+          <a:bodyPr/>
+          <a:lstStyle/>
+          <a:p>
+            <a:endParaRPr lang="ko-KR" altLang="en-US"/>
+          </a:p>
+        </p:txBody>
       </p:sp>
       <p:sp>
         <p:nvSpPr>
@@ -13414,6 +14224,13 @@
           </a:solidFill>
           <a:ln/>
         </p:spPr>
+        <p:txBody>
+          <a:bodyPr/>
+          <a:lstStyle/>
+          <a:p>
+            <a:endParaRPr lang="ko-KR" altLang="en-US"/>
+          </a:p>
+        </p:txBody>
       </p:sp>
       <p:sp>
         <p:nvSpPr>
@@ -13434,6 +14251,13 @@
           </a:solidFill>
           <a:ln/>
         </p:spPr>
+        <p:txBody>
+          <a:bodyPr/>
+          <a:lstStyle/>
+          <a:p>
+            <a:endParaRPr lang="ko-KR" altLang="en-US"/>
+          </a:p>
+        </p:txBody>
       </p:sp>
       <p:sp>
         <p:nvSpPr>
@@ -13542,6 +14366,13 @@
             <a:prstDash val="solid"/>
           </a:ln>
         </p:spPr>
+        <p:txBody>
+          <a:bodyPr/>
+          <a:lstStyle/>
+          <a:p>
+            <a:endParaRPr lang="ko-KR" altLang="en-US"/>
+          </a:p>
+        </p:txBody>
       </p:sp>
       <p:sp>
         <p:nvSpPr>
@@ -13605,6 +14436,13 @@
             <a:tailEnd type="triangle"/>
           </a:ln>
         </p:spPr>
+        <p:txBody>
+          <a:bodyPr/>
+          <a:lstStyle/>
+          <a:p>
+            <a:endParaRPr lang="ko-KR" altLang="en-US"/>
+          </a:p>
+        </p:txBody>
       </p:sp>
       <p:sp>
         <p:nvSpPr>
@@ -13632,6 +14470,13 @@
             <a:prstDash val="solid"/>
           </a:ln>
         </p:spPr>
+        <p:txBody>
+          <a:bodyPr/>
+          <a:lstStyle/>
+          <a:p>
+            <a:endParaRPr lang="ko-KR" altLang="en-US"/>
+          </a:p>
+        </p:txBody>
       </p:sp>
       <p:sp>
         <p:nvSpPr>
@@ -13695,6 +14540,13 @@
             <a:tailEnd type="triangle"/>
           </a:ln>
         </p:spPr>
+        <p:txBody>
+          <a:bodyPr/>
+          <a:lstStyle/>
+          <a:p>
+            <a:endParaRPr lang="ko-KR" altLang="en-US"/>
+          </a:p>
+        </p:txBody>
       </p:sp>
       <p:sp>
         <p:nvSpPr>
@@ -13722,6 +14574,13 @@
             <a:prstDash val="solid"/>
           </a:ln>
         </p:spPr>
+        <p:txBody>
+          <a:bodyPr/>
+          <a:lstStyle/>
+          <a:p>
+            <a:endParaRPr lang="ko-KR" altLang="en-US"/>
+          </a:p>
+        </p:txBody>
       </p:sp>
       <p:sp>
         <p:nvSpPr>
@@ -13864,14 +14723,6 @@
               </a:rPr>
               <a:t> </a:t>
             </a:r>
-            <a:endParaRPr lang="en-US" sz="1100" dirty="0" smtClean="0">
-              <a:solidFill>
-                <a:srgbClr val="6B7583"/>
-              </a:solidFill>
-              <a:latin typeface="Calibri" pitchFamily="34" charset="0"/>
-              <a:ea typeface="Calibri" pitchFamily="34" charset="-122"/>
-              <a:cs typeface="Calibri" pitchFamily="34" charset="-120"/>
-            </a:endParaRPr>
           </a:p>
           <a:p>
             <a:pPr marL="0" indent="0" algn="ctr">
@@ -13881,7 +14732,7 @@
               <a:buNone/>
             </a:pPr>
             <a:r>
-              <a:rPr lang="en-US" sz="1100" dirty="0" err="1" smtClean="0">
+              <a:rPr lang="en-US" sz="1100" dirty="0" err="1">
                 <a:solidFill>
                   <a:srgbClr val="6B7583"/>
                 </a:solidFill>
@@ -13892,7 +14743,7 @@
               <a:t>grep</a:t>
             </a:r>
             <a:r>
-              <a:rPr lang="en-US" sz="1100" dirty="0" smtClean="0">
+              <a:rPr lang="en-US" sz="1100" dirty="0">
                 <a:solidFill>
                   <a:srgbClr val="6B7583"/>
                 </a:solidFill>
@@ -13900,18 +14751,7 @@
                 <a:ea typeface="Calibri" pitchFamily="34" charset="-122"/>
                 <a:cs typeface="Calibri" pitchFamily="34" charset="-120"/>
               </a:rPr>
-              <a:t> </a:t>
-            </a:r>
-            <a:r>
-              <a:rPr lang="en-US" sz="1100" dirty="0">
-                <a:solidFill>
-                  <a:srgbClr val="6B7583"/>
-                </a:solidFill>
-                <a:latin typeface="Calibri" pitchFamily="34" charset="0"/>
-                <a:ea typeface="Calibri" pitchFamily="34" charset="-122"/>
-                <a:cs typeface="Calibri" pitchFamily="34" charset="-120"/>
-              </a:rPr>
-              <a:t>-i hello &lt;file1&gt; &lt;file2&gt; ... 형태로 실행</a:t>
+              <a:t> -i hello &lt;file1&gt; &lt;file2&gt; ... 형태로 실행</a:t>
             </a:r>
             <a:endParaRPr lang="en-US" sz="1100" dirty="0"/>
           </a:p>
@@ -13977,14 +14817,6 @@
               </a:rPr>
               <a:t> </a:t>
             </a:r>
-            <a:endParaRPr lang="en-US" sz="1100" dirty="0" smtClean="0">
-              <a:solidFill>
-                <a:srgbClr val="6B7583"/>
-              </a:solidFill>
-              <a:latin typeface="Calibri" pitchFamily="34" charset="0"/>
-              <a:ea typeface="Calibri" pitchFamily="34" charset="-122"/>
-              <a:cs typeface="Calibri" pitchFamily="34" charset="-120"/>
-            </a:endParaRPr>
           </a:p>
           <a:p>
             <a:pPr marL="0" indent="0" algn="ctr">
@@ -13994,7 +14826,7 @@
               <a:buNone/>
             </a:pPr>
             <a:r>
-              <a:rPr lang="en-US" sz="1100" dirty="0" smtClean="0">
+              <a:rPr lang="en-US" sz="1100" dirty="0">
                 <a:solidFill>
                   <a:srgbClr val="6B7583"/>
                 </a:solidFill>
@@ -14002,18 +14834,7 @@
                 <a:ea typeface="Calibri" pitchFamily="34" charset="-122"/>
                 <a:cs typeface="Calibri" pitchFamily="34" charset="-120"/>
               </a:rPr>
-              <a:t>"</a:t>
-            </a:r>
-            <a:r>
-              <a:rPr lang="en-US" sz="1100" dirty="0">
-                <a:solidFill>
-                  <a:srgbClr val="6B7583"/>
-                </a:solidFill>
-                <a:latin typeface="Calibri" pitchFamily="34" charset="0"/>
-                <a:ea typeface="Calibri" pitchFamily="34" charset="-122"/>
-                <a:cs typeface="Calibri" pitchFamily="34" charset="-120"/>
-              </a:rPr>
-              <a:t>hello"(대소문자 무시)를 검색</a:t>
+              <a:t>"hello"(대소문자 무시)를 검색</a:t>
             </a:r>
             <a:endParaRPr lang="en-US" sz="1100" dirty="0"/>
           </a:p>
@@ -14040,6 +14861,13 @@
           </a:solidFill>
           <a:ln/>
         </p:spPr>
+        <p:txBody>
+          <a:bodyPr/>
+          <a:lstStyle/>
+          <a:p>
+            <a:endParaRPr lang="ko-KR" altLang="en-US"/>
+          </a:p>
+        </p:txBody>
       </p:sp>
       <p:sp>
         <p:nvSpPr>
@@ -14060,6 +14888,13 @@
           </a:solidFill>
           <a:ln/>
         </p:spPr>
+        <p:txBody>
+          <a:bodyPr/>
+          <a:lstStyle/>
+          <a:p>
+            <a:endParaRPr lang="ko-KR" altLang="en-US"/>
+          </a:p>
+        </p:txBody>
       </p:sp>
       <p:sp>
         <p:nvSpPr>
@@ -14173,6 +15008,13 @@
           </a:solidFill>
           <a:ln/>
         </p:spPr>
+        <p:txBody>
+          <a:bodyPr/>
+          <a:lstStyle/>
+          <a:p>
+            <a:endParaRPr lang="ko-KR" altLang="en-US"/>
+          </a:p>
+        </p:txBody>
       </p:sp>
       <p:sp>
         <p:nvSpPr>
@@ -14199,7 +15041,7 @@
               <a:buNone/>
             </a:pPr>
             <a:r>
-              <a:rPr lang="en-US" sz="1300" b="1" dirty="0" smtClean="0">
+              <a:rPr lang="en-US" sz="1300" b="1" dirty="0">
                 <a:solidFill>
                   <a:srgbClr val="1B2028"/>
                 </a:solidFill>
@@ -14397,6 +15239,13 @@
             </a:outerShdw>
           </a:effectLst>
         </p:spPr>
+        <p:txBody>
+          <a:bodyPr/>
+          <a:lstStyle/>
+          <a:p>
+            <a:endParaRPr lang="ko-KR" altLang="en-US"/>
+          </a:p>
+        </p:txBody>
       </p:sp>
       <p:sp>
         <p:nvSpPr>
@@ -14417,6 +15266,13 @@
           </a:solidFill>
           <a:ln/>
         </p:spPr>
+        <p:txBody>
+          <a:bodyPr/>
+          <a:lstStyle/>
+          <a:p>
+            <a:endParaRPr lang="ko-KR" altLang="en-US"/>
+          </a:p>
+        </p:txBody>
       </p:sp>
       <p:sp>
         <p:nvSpPr>
@@ -14437,6 +15293,13 @@
           </a:solidFill>
           <a:ln/>
         </p:spPr>
+        <p:txBody>
+          <a:bodyPr/>
+          <a:lstStyle/>
+          <a:p>
+            <a:endParaRPr lang="ko-KR" altLang="en-US"/>
+          </a:p>
+        </p:txBody>
       </p:sp>
       <p:sp>
         <p:nvSpPr>
@@ -14457,6 +15320,13 @@
           </a:solidFill>
           <a:ln/>
         </p:spPr>
+        <p:txBody>
+          <a:bodyPr/>
+          <a:lstStyle/>
+          <a:p>
+            <a:endParaRPr lang="ko-KR" altLang="en-US"/>
+          </a:p>
+        </p:txBody>
       </p:sp>
       <p:sp>
         <p:nvSpPr>
@@ -14698,6 +15568,13 @@
           </a:solidFill>
           <a:ln/>
         </p:spPr>
+        <p:txBody>
+          <a:bodyPr/>
+          <a:lstStyle/>
+          <a:p>
+            <a:endParaRPr lang="ko-KR" altLang="en-US"/>
+          </a:p>
+        </p:txBody>
       </p:sp>
       <p:sp>
         <p:nvSpPr>
@@ -14718,6 +15595,13 @@
           </a:solidFill>
           <a:ln/>
         </p:spPr>
+        <p:txBody>
+          <a:bodyPr/>
+          <a:lstStyle/>
+          <a:p>
+            <a:endParaRPr lang="ko-KR" altLang="en-US"/>
+          </a:p>
+        </p:txBody>
       </p:sp>
       <p:sp>
         <p:nvSpPr>
@@ -14757,7 +15641,7 @@
               <a:t> </a:t>
             </a:r>
             <a:r>
-              <a:rPr lang="en-US" sz="1250" dirty="0" err="1" smtClean="0">
+              <a:rPr lang="en-US" sz="1250" dirty="0" err="1">
                 <a:solidFill>
                   <a:srgbClr val="1B2028"/>
                 </a:solidFill>
@@ -14765,7 +15649,18 @@
                 <a:ea typeface="Calibri" pitchFamily="34" charset="-122"/>
                 <a:cs typeface="Calibri" pitchFamily="34" charset="-120"/>
               </a:rPr>
-              <a:t>sed</a:t>
+              <a:t>sed는</a:t>
+            </a:r>
+            <a:r>
+              <a:rPr lang="en-US" sz="1250" dirty="0">
+                <a:solidFill>
+                  <a:srgbClr val="1B2028"/>
+                </a:solidFill>
+                <a:latin typeface="Calibri" pitchFamily="34" charset="0"/>
+                <a:ea typeface="Calibri" pitchFamily="34" charset="-122"/>
+                <a:cs typeface="Calibri" pitchFamily="34" charset="-120"/>
+              </a:rPr>
+              <a:t> 기본적으로 원본을 열어 고치지 않고, 한 줄씩 읽으며 바뀐 결과를 화면에 출력합니다. -i 옵션을 주면 그 결과로 원본 파일 자체를 덮어쓰므로, 실수에 대비해 sed -i.bak 처럼 백업 확장자를 함께 쓰는 </a:t>
             </a:r>
             <a:r>
               <a:rPr lang="en-US" sz="1250" dirty="0" err="1">
@@ -14776,7 +15671,7 @@
                 <a:ea typeface="Calibri" pitchFamily="34" charset="-122"/>
                 <a:cs typeface="Calibri" pitchFamily="34" charset="-120"/>
               </a:rPr>
-              <a:t>는</a:t>
+              <a:t>것이</a:t>
             </a:r>
             <a:r>
               <a:rPr lang="en-US" sz="1250" dirty="0">
@@ -14787,7 +15682,7 @@
                 <a:ea typeface="Calibri" pitchFamily="34" charset="-122"/>
                 <a:cs typeface="Calibri" pitchFamily="34" charset="-120"/>
               </a:rPr>
-              <a:t> 기본적으로 원본을 열어 고치지 않고, 한 줄씩 읽으며 바뀐 결과를 화면에 출력합니다. -i 옵션을 주면 그 결과로 원본 파일 자체를 덮어쓰므로, 실수에 대비해 sed -i.bak 처럼 백업 확장자를 함께 쓰는 </a:t>
+              <a:t> </a:t>
             </a:r>
             <a:r>
               <a:rPr lang="en-US" sz="1250" dirty="0" err="1">
@@ -14798,7 +15693,7 @@
                 <a:ea typeface="Calibri" pitchFamily="34" charset="-122"/>
                 <a:cs typeface="Calibri" pitchFamily="34" charset="-120"/>
               </a:rPr>
-              <a:t>것이</a:t>
+              <a:t>안전합니다</a:t>
             </a:r>
             <a:r>
               <a:rPr lang="en-US" sz="1250" dirty="0">
@@ -14809,10 +15704,10 @@
                 <a:ea typeface="Calibri" pitchFamily="34" charset="-122"/>
                 <a:cs typeface="Calibri" pitchFamily="34" charset="-120"/>
               </a:rPr>
-              <a:t> </a:t>
-            </a:r>
-            <a:r>
-              <a:rPr lang="en-US" sz="1250" dirty="0" err="1" smtClean="0">
+              <a:t>(</a:t>
+            </a:r>
+            <a:r>
+              <a:rPr lang="en-US" sz="1250" dirty="0" err="1">
                 <a:solidFill>
                   <a:srgbClr val="1B2028"/>
                 </a:solidFill>
@@ -14820,10 +15715,10 @@
                 <a:ea typeface="Calibri" pitchFamily="34" charset="-122"/>
                 <a:cs typeface="Calibri" pitchFamily="34" charset="-120"/>
               </a:rPr>
-              <a:t>안전합니다</a:t>
-            </a:r>
-            <a:r>
-              <a:rPr lang="en-US" sz="1250" dirty="0">
+              <a:t>file.txt.bak</a:t>
+            </a:r>
+            <a:r>
+              <a:rPr lang="ko-KR" altLang="en-US" sz="1250" dirty="0">
                 <a:solidFill>
                   <a:srgbClr val="1B2028"/>
                 </a:solidFill>
@@ -14831,32 +15726,10 @@
                 <a:ea typeface="Calibri" pitchFamily="34" charset="-122"/>
                 <a:cs typeface="Calibri" pitchFamily="34" charset="-120"/>
               </a:rPr>
-              <a:t>(</a:t>
-            </a:r>
-            <a:r>
-              <a:rPr lang="en-US" sz="1250" dirty="0" err="1" smtClean="0">
-                <a:solidFill>
-                  <a:srgbClr val="1B2028"/>
-                </a:solidFill>
-                <a:latin typeface="Calibri" pitchFamily="34" charset="0"/>
-                <a:ea typeface="Calibri" pitchFamily="34" charset="-122"/>
-                <a:cs typeface="Calibri" pitchFamily="34" charset="-120"/>
-              </a:rPr>
-              <a:t>file.txt.bak</a:t>
-            </a:r>
-            <a:r>
-              <a:rPr lang="ko-KR" altLang="en-US" sz="1250" dirty="0" smtClean="0">
-                <a:solidFill>
-                  <a:srgbClr val="1B2028"/>
-                </a:solidFill>
-                <a:latin typeface="Calibri" pitchFamily="34" charset="0"/>
-                <a:ea typeface="Calibri" pitchFamily="34" charset="-122"/>
-                <a:cs typeface="Calibri" pitchFamily="34" charset="-120"/>
-              </a:rPr>
               <a:t>에 원본</a:t>
             </a:r>
             <a:r>
-              <a:rPr lang="en-US" altLang="ko-KR" sz="1250" dirty="0" smtClean="0">
+              <a:rPr lang="en-US" altLang="ko-KR" sz="1250" dirty="0">
                 <a:solidFill>
                   <a:srgbClr val="1B2028"/>
                 </a:solidFill>
@@ -14898,6 +15771,13 @@
             </a:outerShdw>
           </a:effectLst>
         </p:spPr>
+        <p:txBody>
+          <a:bodyPr/>
+          <a:lstStyle/>
+          <a:p>
+            <a:endParaRPr lang="ko-KR" altLang="en-US"/>
+          </a:p>
+        </p:txBody>
       </p:sp>
       <p:sp>
         <p:nvSpPr>
@@ -14918,6 +15798,13 @@
           </a:solidFill>
           <a:ln/>
         </p:spPr>
+        <p:txBody>
+          <a:bodyPr/>
+          <a:lstStyle/>
+          <a:p>
+            <a:endParaRPr lang="ko-KR" altLang="en-US"/>
+          </a:p>
+        </p:txBody>
       </p:sp>
       <p:sp>
         <p:nvSpPr>
@@ -14938,6 +15825,13 @@
           </a:solidFill>
           <a:ln/>
         </p:spPr>
+        <p:txBody>
+          <a:bodyPr/>
+          <a:lstStyle/>
+          <a:p>
+            <a:endParaRPr lang="ko-KR" altLang="en-US"/>
+          </a:p>
+        </p:txBody>
       </p:sp>
       <p:sp>
         <p:nvSpPr>
@@ -14958,6 +15852,13 @@
           </a:solidFill>
           <a:ln/>
         </p:spPr>
+        <p:txBody>
+          <a:bodyPr/>
+          <a:lstStyle/>
+          <a:p>
+            <a:endParaRPr lang="ko-KR" altLang="en-US"/>
+          </a:p>
+        </p:txBody>
       </p:sp>
       <p:sp>
         <p:nvSpPr>
@@ -15161,6 +16062,13 @@
             </a:outerShdw>
           </a:effectLst>
         </p:spPr>
+        <p:txBody>
+          <a:bodyPr/>
+          <a:lstStyle/>
+          <a:p>
+            <a:endParaRPr lang="ko-KR" altLang="en-US"/>
+          </a:p>
+        </p:txBody>
       </p:sp>
       <p:sp>
         <p:nvSpPr>
@@ -15564,6 +16472,13 @@
           </a:solidFill>
           <a:ln/>
         </p:spPr>
+        <p:txBody>
+          <a:bodyPr/>
+          <a:lstStyle/>
+          <a:p>
+            <a:endParaRPr lang="ko-KR" altLang="en-US"/>
+          </a:p>
+        </p:txBody>
       </p:sp>
       <p:sp>
         <p:nvSpPr>
@@ -15590,7 +16505,7 @@
               <a:buNone/>
             </a:pPr>
             <a:r>
-              <a:rPr lang="en-US" sz="1300" b="1" dirty="0" smtClean="0">
+              <a:rPr lang="en-US" sz="1300" b="1" dirty="0">
                 <a:solidFill>
                   <a:srgbClr val="1B2028"/>
                 </a:solidFill>
@@ -15742,6 +16657,13 @@
           </a:solidFill>
           <a:ln/>
         </p:spPr>
+        <p:txBody>
+          <a:bodyPr/>
+          <a:lstStyle/>
+          <a:p>
+            <a:endParaRPr lang="ko-KR" altLang="en-US"/>
+          </a:p>
+        </p:txBody>
       </p:sp>
       <p:sp>
         <p:nvSpPr>
@@ -15764,6 +16686,13 @@
           </a:solidFill>
           <a:ln/>
         </p:spPr>
+        <p:txBody>
+          <a:bodyPr/>
+          <a:lstStyle/>
+          <a:p>
+            <a:endParaRPr lang="ko-KR" altLang="en-US"/>
+          </a:p>
+        </p:txBody>
       </p:sp>
       <p:sp>
         <p:nvSpPr>
@@ -15784,6 +16713,13 @@
           </a:solidFill>
           <a:ln/>
         </p:spPr>
+        <p:txBody>
+          <a:bodyPr/>
+          <a:lstStyle/>
+          <a:p>
+            <a:endParaRPr lang="ko-KR" altLang="en-US"/>
+          </a:p>
+        </p:txBody>
       </p:sp>
       <p:sp>
         <p:nvSpPr>
@@ -15852,6 +16788,13 @@
             </a:outerShdw>
           </a:effectLst>
         </p:spPr>
+        <p:txBody>
+          <a:bodyPr/>
+          <a:lstStyle/>
+          <a:p>
+            <a:endParaRPr lang="ko-KR" altLang="en-US"/>
+          </a:p>
+        </p:txBody>
       </p:sp>
       <p:sp>
         <p:nvSpPr>
@@ -15872,6 +16815,13 @@
           </a:solidFill>
           <a:ln/>
         </p:spPr>
+        <p:txBody>
+          <a:bodyPr/>
+          <a:lstStyle/>
+          <a:p>
+            <a:endParaRPr lang="ko-KR" altLang="en-US"/>
+          </a:p>
+        </p:txBody>
       </p:sp>
       <p:sp>
         <p:nvSpPr>
@@ -15892,6 +16842,13 @@
           </a:solidFill>
           <a:ln/>
         </p:spPr>
+        <p:txBody>
+          <a:bodyPr/>
+          <a:lstStyle/>
+          <a:p>
+            <a:endParaRPr lang="ko-KR" altLang="en-US"/>
+          </a:p>
+        </p:txBody>
       </p:sp>
       <p:sp>
         <p:nvSpPr>
@@ -15912,6 +16869,13 @@
           </a:solidFill>
           <a:ln/>
         </p:spPr>
+        <p:txBody>
+          <a:bodyPr/>
+          <a:lstStyle/>
+          <a:p>
+            <a:endParaRPr lang="ko-KR" altLang="en-US"/>
+          </a:p>
+        </p:txBody>
       </p:sp>
       <p:sp>
         <p:nvSpPr>
@@ -15991,7 +16955,7 @@
               <a:t>$ tar -czvf archive.tar.gz </a:t>
             </a:r>
             <a:r>
-              <a:rPr lang="en-US" sz="1350" dirty="0" smtClean="0">
+              <a:rPr lang="en-US" sz="1350" dirty="0">
                 <a:solidFill>
                   <a:srgbClr val="F5F7F8"/>
                 </a:solidFill>
@@ -15999,18 +16963,7 @@
                 <a:ea typeface="Courier New" pitchFamily="34" charset="-122"/>
                 <a:cs typeface="Courier New" pitchFamily="34" charset="-120"/>
               </a:rPr>
-              <a:t> </a:t>
-            </a:r>
-            <a:r>
-              <a:rPr lang="en-US" sz="1350" dirty="0">
-                <a:solidFill>
-                  <a:srgbClr val="F5F7F8"/>
-                </a:solidFill>
-                <a:latin typeface="Courier New" pitchFamily="34" charset="0"/>
-                <a:ea typeface="Courier New" pitchFamily="34" charset="-122"/>
-                <a:cs typeface="Courier New" pitchFamily="34" charset="-120"/>
-              </a:rPr>
-              <a:t>/path/directory</a:t>
+              <a:t> /path/directory</a:t>
             </a:r>
             <a:endParaRPr lang="en-US" sz="1350" dirty="0"/>
           </a:p>
@@ -16172,6 +17125,13 @@
             </a:outerShdw>
           </a:effectLst>
         </p:spPr>
+        <p:txBody>
+          <a:bodyPr/>
+          <a:lstStyle/>
+          <a:p>
+            <a:endParaRPr lang="ko-KR" altLang="en-US"/>
+          </a:p>
+        </p:txBody>
       </p:sp>
       <p:sp>
         <p:nvSpPr>
@@ -16192,6 +17152,13 @@
           </a:solidFill>
           <a:ln/>
         </p:spPr>
+        <p:txBody>
+          <a:bodyPr/>
+          <a:lstStyle/>
+          <a:p>
+            <a:endParaRPr lang="ko-KR" altLang="en-US"/>
+          </a:p>
+        </p:txBody>
       </p:sp>
       <p:sp>
         <p:nvSpPr>
@@ -16212,6 +17179,13 @@
           </a:solidFill>
           <a:ln/>
         </p:spPr>
+        <p:txBody>
+          <a:bodyPr/>
+          <a:lstStyle/>
+          <a:p>
+            <a:endParaRPr lang="ko-KR" altLang="en-US"/>
+          </a:p>
+        </p:txBody>
       </p:sp>
       <p:sp>
         <p:nvSpPr>
@@ -16232,6 +17206,13 @@
           </a:solidFill>
           <a:ln/>
         </p:spPr>
+        <p:txBody>
+          <a:bodyPr/>
+          <a:lstStyle/>
+          <a:p>
+            <a:endParaRPr lang="ko-KR" altLang="en-US"/>
+          </a:p>
+        </p:txBody>
       </p:sp>
       <p:sp>
         <p:nvSpPr>
@@ -16385,6 +17366,13 @@
           </a:solidFill>
           <a:ln/>
         </p:spPr>
+        <p:txBody>
+          <a:bodyPr/>
+          <a:lstStyle/>
+          <a:p>
+            <a:endParaRPr lang="ko-KR" altLang="en-US"/>
+          </a:p>
+        </p:txBody>
       </p:sp>
       <p:sp>
         <p:nvSpPr>
@@ -16411,7 +17399,7 @@
               <a:buNone/>
             </a:pPr>
             <a:r>
-              <a:rPr lang="en-US" sz="1300" b="1" dirty="0" smtClean="0">
+              <a:rPr lang="en-US" sz="1300" b="1" dirty="0">
                 <a:solidFill>
                   <a:srgbClr val="1B2028"/>
                 </a:solidFill>
@@ -16609,6 +17597,13 @@
             </a:outerShdw>
           </a:effectLst>
         </p:spPr>
+        <p:txBody>
+          <a:bodyPr/>
+          <a:lstStyle/>
+          <a:p>
+            <a:endParaRPr lang="ko-KR" altLang="en-US"/>
+          </a:p>
+        </p:txBody>
       </p:sp>
       <p:sp>
         <p:nvSpPr>
@@ -16629,6 +17624,13 @@
           </a:solidFill>
           <a:ln/>
         </p:spPr>
+        <p:txBody>
+          <a:bodyPr/>
+          <a:lstStyle/>
+          <a:p>
+            <a:endParaRPr lang="ko-KR" altLang="en-US"/>
+          </a:p>
+        </p:txBody>
       </p:sp>
       <p:sp>
         <p:nvSpPr>
@@ -16649,6 +17651,13 @@
           </a:solidFill>
           <a:ln/>
         </p:spPr>
+        <p:txBody>
+          <a:bodyPr/>
+          <a:lstStyle/>
+          <a:p>
+            <a:endParaRPr lang="ko-KR" altLang="en-US"/>
+          </a:p>
+        </p:txBody>
       </p:sp>
       <p:sp>
         <p:nvSpPr>
@@ -16669,6 +17678,13 @@
           </a:solidFill>
           <a:ln/>
         </p:spPr>
+        <p:txBody>
+          <a:bodyPr/>
+          <a:lstStyle/>
+          <a:p>
+            <a:endParaRPr lang="ko-KR" altLang="en-US"/>
+          </a:p>
+        </p:txBody>
       </p:sp>
       <p:sp>
         <p:nvSpPr>
@@ -16832,6 +17848,13 @@
           </a:solidFill>
           <a:ln/>
         </p:spPr>
+        <p:txBody>
+          <a:bodyPr/>
+          <a:lstStyle/>
+          <a:p>
+            <a:endParaRPr lang="ko-KR" altLang="en-US"/>
+          </a:p>
+        </p:txBody>
       </p:sp>
       <p:sp>
         <p:nvSpPr>
@@ -16852,6 +17875,13 @@
           </a:solidFill>
           <a:ln/>
         </p:spPr>
+        <p:txBody>
+          <a:bodyPr/>
+          <a:lstStyle/>
+          <a:p>
+            <a:endParaRPr lang="ko-KR" altLang="en-US"/>
+          </a:p>
+        </p:txBody>
       </p:sp>
       <p:sp>
         <p:nvSpPr>
@@ -16934,6 +17964,13 @@
             </a:outerShdw>
           </a:effectLst>
         </p:spPr>
+        <p:txBody>
+          <a:bodyPr/>
+          <a:lstStyle/>
+          <a:p>
+            <a:endParaRPr lang="ko-KR" altLang="en-US"/>
+          </a:p>
+        </p:txBody>
       </p:sp>
       <p:sp>
         <p:nvSpPr>
@@ -16954,6 +17991,13 @@
           </a:solidFill>
           <a:ln/>
         </p:spPr>
+        <p:txBody>
+          <a:bodyPr/>
+          <a:lstStyle/>
+          <a:p>
+            <a:endParaRPr lang="ko-KR" altLang="en-US"/>
+          </a:p>
+        </p:txBody>
       </p:sp>
       <p:sp>
         <p:nvSpPr>
@@ -16974,6 +18018,13 @@
           </a:solidFill>
           <a:ln/>
         </p:spPr>
+        <p:txBody>
+          <a:bodyPr/>
+          <a:lstStyle/>
+          <a:p>
+            <a:endParaRPr lang="ko-KR" altLang="en-US"/>
+          </a:p>
+        </p:txBody>
       </p:sp>
       <p:sp>
         <p:nvSpPr>
@@ -16994,6 +18045,13 @@
           </a:solidFill>
           <a:ln/>
         </p:spPr>
+        <p:txBody>
+          <a:bodyPr/>
+          <a:lstStyle/>
+          <a:p>
+            <a:endParaRPr lang="ko-KR" altLang="en-US"/>
+          </a:p>
+        </p:txBody>
       </p:sp>
       <p:sp>
         <p:nvSpPr>
@@ -17167,6 +18225,13 @@
           </a:solidFill>
           <a:ln/>
         </p:spPr>
+        <p:txBody>
+          <a:bodyPr/>
+          <a:lstStyle/>
+          <a:p>
+            <a:endParaRPr lang="ko-KR" altLang="en-US"/>
+          </a:p>
+        </p:txBody>
       </p:sp>
       <p:sp>
         <p:nvSpPr>
@@ -17193,7 +18258,7 @@
               <a:buNone/>
             </a:pPr>
             <a:r>
-              <a:rPr lang="en-US" sz="1300" b="1" dirty="0" smtClean="0">
+              <a:rPr lang="en-US" sz="1300" b="1" dirty="0">
                 <a:solidFill>
                   <a:srgbClr val="1B2028"/>
                 </a:solidFill>
@@ -17396,6 +18461,13 @@
             </a:outerShdw>
           </a:effectLst>
         </p:spPr>
+        <p:txBody>
+          <a:bodyPr/>
+          <a:lstStyle/>
+          <a:p>
+            <a:endParaRPr lang="ko-KR" altLang="en-US"/>
+          </a:p>
+        </p:txBody>
       </p:sp>
       <p:sp>
         <p:nvSpPr>
@@ -17416,6 +18488,13 @@
           </a:solidFill>
           <a:ln/>
         </p:spPr>
+        <p:txBody>
+          <a:bodyPr/>
+          <a:lstStyle/>
+          <a:p>
+            <a:endParaRPr lang="ko-KR" altLang="en-US"/>
+          </a:p>
+        </p:txBody>
       </p:sp>
       <p:sp>
         <p:nvSpPr>
@@ -17570,6 +18649,13 @@
             </a:outerShdw>
           </a:effectLst>
         </p:spPr>
+        <p:txBody>
+          <a:bodyPr/>
+          <a:lstStyle/>
+          <a:p>
+            <a:endParaRPr lang="ko-KR" altLang="en-US"/>
+          </a:p>
+        </p:txBody>
       </p:sp>
       <p:sp>
         <p:nvSpPr>
@@ -17590,6 +18676,13 @@
           </a:solidFill>
           <a:ln/>
         </p:spPr>
+        <p:txBody>
+          <a:bodyPr/>
+          <a:lstStyle/>
+          <a:p>
+            <a:endParaRPr lang="ko-KR" altLang="en-US"/>
+          </a:p>
+        </p:txBody>
       </p:sp>
       <p:sp>
         <p:nvSpPr>
@@ -17739,6 +18832,13 @@
             </a:outerShdw>
           </a:effectLst>
         </p:spPr>
+        <p:txBody>
+          <a:bodyPr/>
+          <a:lstStyle/>
+          <a:p>
+            <a:endParaRPr lang="ko-KR" altLang="en-US"/>
+          </a:p>
+        </p:txBody>
       </p:sp>
       <p:sp>
         <p:nvSpPr>
@@ -17759,6 +18859,13 @@
           </a:solidFill>
           <a:ln/>
         </p:spPr>
+        <p:txBody>
+          <a:bodyPr/>
+          <a:lstStyle/>
+          <a:p>
+            <a:endParaRPr lang="ko-KR" altLang="en-US"/>
+          </a:p>
+        </p:txBody>
       </p:sp>
       <p:sp>
         <p:nvSpPr>
@@ -17779,6 +18886,13 @@
           </a:solidFill>
           <a:ln/>
         </p:spPr>
+        <p:txBody>
+          <a:bodyPr/>
+          <a:lstStyle/>
+          <a:p>
+            <a:endParaRPr lang="ko-KR" altLang="en-US"/>
+          </a:p>
+        </p:txBody>
       </p:sp>
       <p:sp>
         <p:nvSpPr>
@@ -17799,6 +18913,13 @@
           </a:solidFill>
           <a:ln/>
         </p:spPr>
+        <p:txBody>
+          <a:bodyPr/>
+          <a:lstStyle/>
+          <a:p>
+            <a:endParaRPr lang="ko-KR" altLang="en-US"/>
+          </a:p>
+        </p:txBody>
       </p:sp>
       <p:sp>
         <p:nvSpPr>
@@ -17958,6 +19079,13 @@
             </a:outerShdw>
           </a:effectLst>
         </p:spPr>
+        <p:txBody>
+          <a:bodyPr/>
+          <a:lstStyle/>
+          <a:p>
+            <a:endParaRPr lang="ko-KR" altLang="en-US"/>
+          </a:p>
+        </p:txBody>
       </p:sp>
       <p:sp>
         <p:nvSpPr>
@@ -17978,6 +19106,13 @@
           </a:solidFill>
           <a:ln/>
         </p:spPr>
+        <p:txBody>
+          <a:bodyPr/>
+          <a:lstStyle/>
+          <a:p>
+            <a:endParaRPr lang="ko-KR" altLang="en-US"/>
+          </a:p>
+        </p:txBody>
       </p:sp>
       <p:sp>
         <p:nvSpPr>
@@ -17998,6 +19133,13 @@
           </a:solidFill>
           <a:ln/>
         </p:spPr>
+        <p:txBody>
+          <a:bodyPr/>
+          <a:lstStyle/>
+          <a:p>
+            <a:endParaRPr lang="ko-KR" altLang="en-US"/>
+          </a:p>
+        </p:txBody>
       </p:sp>
       <p:sp>
         <p:nvSpPr>
@@ -18018,6 +19160,13 @@
           </a:solidFill>
           <a:ln/>
         </p:spPr>
+        <p:txBody>
+          <a:bodyPr/>
+          <a:lstStyle/>
+          <a:p>
+            <a:endParaRPr lang="ko-KR" altLang="en-US"/>
+          </a:p>
+        </p:txBody>
       </p:sp>
       <p:sp>
         <p:nvSpPr>
@@ -18259,6 +19408,13 @@
           </a:solidFill>
           <a:ln/>
         </p:spPr>
+        <p:txBody>
+          <a:bodyPr/>
+          <a:lstStyle/>
+          <a:p>
+            <a:endParaRPr lang="ko-KR" altLang="en-US"/>
+          </a:p>
+        </p:txBody>
       </p:sp>
       <p:sp>
         <p:nvSpPr>
@@ -18279,6 +19435,13 @@
           </a:solidFill>
           <a:ln/>
         </p:spPr>
+        <p:txBody>
+          <a:bodyPr/>
+          <a:lstStyle/>
+          <a:p>
+            <a:endParaRPr lang="ko-KR" altLang="en-US"/>
+          </a:p>
+        </p:txBody>
       </p:sp>
       <p:sp>
         <p:nvSpPr>
@@ -18384,6 +19547,13 @@
           </a:solidFill>
           <a:ln/>
         </p:spPr>
+        <p:txBody>
+          <a:bodyPr/>
+          <a:lstStyle/>
+          <a:p>
+            <a:endParaRPr lang="ko-KR" altLang="en-US"/>
+          </a:p>
+        </p:txBody>
       </p:sp>
       <p:sp>
         <p:nvSpPr>
@@ -18410,7 +19580,7 @@
               <a:buNone/>
             </a:pPr>
             <a:r>
-              <a:rPr lang="en-US" sz="1300" b="1" dirty="0" smtClean="0">
+              <a:rPr lang="en-US" sz="1300" b="1" dirty="0">
                 <a:solidFill>
                   <a:srgbClr val="1B2028"/>
                 </a:solidFill>
@@ -18574,6 +19744,13 @@
             </a:outerShdw>
           </a:effectLst>
         </p:spPr>
+        <p:txBody>
+          <a:bodyPr/>
+          <a:lstStyle/>
+          <a:p>
+            <a:endParaRPr lang="ko-KR" altLang="en-US"/>
+          </a:p>
+        </p:txBody>
       </p:sp>
       <p:sp>
         <p:nvSpPr>
@@ -18689,6 +19866,13 @@
             </a:outerShdw>
           </a:effectLst>
         </p:spPr>
+        <p:txBody>
+          <a:bodyPr/>
+          <a:lstStyle/>
+          <a:p>
+            <a:endParaRPr lang="ko-KR" altLang="en-US"/>
+          </a:p>
+        </p:txBody>
       </p:sp>
       <p:sp>
         <p:nvSpPr>
@@ -18797,6 +19981,13 @@
             <a:prstDash val="solid"/>
           </a:ln>
         </p:spPr>
+        <p:txBody>
+          <a:bodyPr/>
+          <a:lstStyle/>
+          <a:p>
+            <a:endParaRPr lang="ko-KR" altLang="en-US"/>
+          </a:p>
+        </p:txBody>
       </p:sp>
       <p:sp>
         <p:nvSpPr>
@@ -18886,6 +20077,13 @@
             <a:prstDash val="solid"/>
           </a:ln>
         </p:spPr>
+        <p:txBody>
+          <a:bodyPr/>
+          <a:lstStyle/>
+          <a:p>
+            <a:endParaRPr lang="ko-KR" altLang="en-US"/>
+          </a:p>
+        </p:txBody>
       </p:sp>
       <p:sp>
         <p:nvSpPr>
@@ -18975,6 +20173,13 @@
             <a:prstDash val="solid"/>
           </a:ln>
         </p:spPr>
+        <p:txBody>
+          <a:bodyPr/>
+          <a:lstStyle/>
+          <a:p>
+            <a:endParaRPr lang="ko-KR" altLang="en-US"/>
+          </a:p>
+        </p:txBody>
       </p:sp>
       <p:sp>
         <p:nvSpPr>
@@ -19064,6 +20269,13 @@
             <a:prstDash val="solid"/>
           </a:ln>
         </p:spPr>
+        <p:txBody>
+          <a:bodyPr/>
+          <a:lstStyle/>
+          <a:p>
+            <a:endParaRPr lang="ko-KR" altLang="en-US"/>
+          </a:p>
+        </p:txBody>
       </p:sp>
       <p:sp>
         <p:nvSpPr>
@@ -19127,6 +20339,13 @@
             <a:tailEnd type="triangle"/>
           </a:ln>
         </p:spPr>
+        <p:txBody>
+          <a:bodyPr/>
+          <a:lstStyle/>
+          <a:p>
+            <a:endParaRPr lang="ko-KR" altLang="en-US"/>
+          </a:p>
+        </p:txBody>
       </p:sp>
       <p:sp>
         <p:nvSpPr>
@@ -19151,6 +20370,13 @@
             <a:tailEnd type="triangle"/>
           </a:ln>
         </p:spPr>
+        <p:txBody>
+          <a:bodyPr/>
+          <a:lstStyle/>
+          <a:p>
+            <a:endParaRPr lang="ko-KR" altLang="en-US"/>
+          </a:p>
+        </p:txBody>
       </p:sp>
       <p:sp>
         <p:nvSpPr>
@@ -19214,6 +20440,13 @@
             <a:tailEnd type="triangle"/>
           </a:ln>
         </p:spPr>
+        <p:txBody>
+          <a:bodyPr/>
+          <a:lstStyle/>
+          <a:p>
+            <a:endParaRPr lang="ko-KR" altLang="en-US"/>
+          </a:p>
+        </p:txBody>
       </p:sp>
       <p:sp>
         <p:nvSpPr>
@@ -19236,6 +20469,13 @@
           </a:solidFill>
           <a:ln/>
         </p:spPr>
+        <p:txBody>
+          <a:bodyPr/>
+          <a:lstStyle/>
+          <a:p>
+            <a:endParaRPr lang="ko-KR" altLang="en-US"/>
+          </a:p>
+        </p:txBody>
       </p:sp>
       <p:sp>
         <p:nvSpPr>
@@ -19256,6 +20496,13 @@
           </a:solidFill>
           <a:ln/>
         </p:spPr>
+        <p:txBody>
+          <a:bodyPr/>
+          <a:lstStyle/>
+          <a:p>
+            <a:endParaRPr lang="ko-KR" altLang="en-US"/>
+          </a:p>
+        </p:txBody>
       </p:sp>
       <p:sp>
         <p:nvSpPr>
@@ -19485,6 +20732,13 @@
             </a:outerShdw>
           </a:effectLst>
         </p:spPr>
+        <p:txBody>
+          <a:bodyPr/>
+          <a:lstStyle/>
+          <a:p>
+            <a:endParaRPr lang="ko-KR" altLang="en-US"/>
+          </a:p>
+        </p:txBody>
       </p:sp>
       <p:sp>
         <p:nvSpPr>
@@ -19505,6 +20759,13 @@
           </a:solidFill>
           <a:ln/>
         </p:spPr>
+        <p:txBody>
+          <a:bodyPr/>
+          <a:lstStyle/>
+          <a:p>
+            <a:endParaRPr lang="ko-KR" altLang="en-US"/>
+          </a:p>
+        </p:txBody>
       </p:sp>
       <p:sp>
         <p:nvSpPr>
@@ -19525,6 +20786,13 @@
           </a:solidFill>
           <a:ln/>
         </p:spPr>
+        <p:txBody>
+          <a:bodyPr/>
+          <a:lstStyle/>
+          <a:p>
+            <a:endParaRPr lang="ko-KR" altLang="en-US"/>
+          </a:p>
+        </p:txBody>
       </p:sp>
       <p:sp>
         <p:nvSpPr>
@@ -19545,6 +20813,13 @@
           </a:solidFill>
           <a:ln/>
         </p:spPr>
+        <p:txBody>
+          <a:bodyPr/>
+          <a:lstStyle/>
+          <a:p>
+            <a:endParaRPr lang="ko-KR" altLang="en-US"/>
+          </a:p>
+        </p:txBody>
       </p:sp>
       <p:sp>
         <p:nvSpPr>
@@ -19809,6 +21084,13 @@
             </a:outerShdw>
           </a:effectLst>
         </p:spPr>
+        <p:txBody>
+          <a:bodyPr/>
+          <a:lstStyle/>
+          <a:p>
+            <a:endParaRPr lang="ko-KR" altLang="en-US"/>
+          </a:p>
+        </p:txBody>
       </p:sp>
       <p:sp>
         <p:nvSpPr>
@@ -20030,6 +21312,13 @@
           </a:solidFill>
           <a:ln/>
         </p:spPr>
+        <p:txBody>
+          <a:bodyPr/>
+          <a:lstStyle/>
+          <a:p>
+            <a:endParaRPr lang="ko-KR" altLang="en-US"/>
+          </a:p>
+        </p:txBody>
       </p:sp>
       <p:sp>
         <p:nvSpPr>
@@ -20131,6 +21420,13 @@
           </a:solidFill>
           <a:ln/>
         </p:spPr>
+        <p:txBody>
+          <a:bodyPr/>
+          <a:lstStyle/>
+          <a:p>
+            <a:endParaRPr lang="ko-KR" altLang="en-US"/>
+          </a:p>
+        </p:txBody>
       </p:sp>
       <p:sp>
         <p:nvSpPr>
@@ -20232,6 +21528,13 @@
           </a:solidFill>
           <a:ln/>
         </p:spPr>
+        <p:txBody>
+          <a:bodyPr/>
+          <a:lstStyle/>
+          <a:p>
+            <a:endParaRPr lang="ko-KR" altLang="en-US"/>
+          </a:p>
+        </p:txBody>
       </p:sp>
       <p:sp>
         <p:nvSpPr>
@@ -20333,6 +21636,13 @@
           </a:solidFill>
           <a:ln/>
         </p:spPr>
+        <p:txBody>
+          <a:bodyPr/>
+          <a:lstStyle/>
+          <a:p>
+            <a:endParaRPr lang="ko-KR" altLang="en-US"/>
+          </a:p>
+        </p:txBody>
       </p:sp>
       <p:sp>
         <p:nvSpPr>
@@ -20434,6 +21744,13 @@
           </a:solidFill>
           <a:ln/>
         </p:spPr>
+        <p:txBody>
+          <a:bodyPr/>
+          <a:lstStyle/>
+          <a:p>
+            <a:endParaRPr lang="ko-KR" altLang="en-US"/>
+          </a:p>
+        </p:txBody>
       </p:sp>
       <p:sp>
         <p:nvSpPr>
@@ -20535,6 +21852,13 @@
           </a:solidFill>
           <a:ln/>
         </p:spPr>
+        <p:txBody>
+          <a:bodyPr/>
+          <a:lstStyle/>
+          <a:p>
+            <a:endParaRPr lang="ko-KR" altLang="en-US"/>
+          </a:p>
+        </p:txBody>
       </p:sp>
       <p:sp>
         <p:nvSpPr>
@@ -20636,6 +21960,13 @@
           </a:solidFill>
           <a:ln/>
         </p:spPr>
+        <p:txBody>
+          <a:bodyPr/>
+          <a:lstStyle/>
+          <a:p>
+            <a:endParaRPr lang="ko-KR" altLang="en-US"/>
+          </a:p>
+        </p:txBody>
       </p:sp>
       <p:sp>
         <p:nvSpPr>
@@ -21068,7 +22399,7 @@
               <a:t> </a:t>
             </a:r>
             <a:r>
-              <a:rPr lang="en-US" sz="1500" dirty="0" err="1" smtClean="0">
+              <a:rPr lang="en-US" sz="1500" dirty="0" err="1">
                 <a:solidFill>
                   <a:srgbClr val="1B2028"/>
                 </a:solidFill>
@@ -21110,6 +22441,13 @@
             </a:outerShdw>
           </a:effectLst>
         </p:spPr>
+        <p:txBody>
+          <a:bodyPr/>
+          <a:lstStyle/>
+          <a:p>
+            <a:endParaRPr lang="ko-KR" altLang="en-US"/>
+          </a:p>
+        </p:txBody>
       </p:sp>
       <p:sp>
         <p:nvSpPr>
@@ -21130,6 +22468,13 @@
           </a:solidFill>
           <a:ln/>
         </p:spPr>
+        <p:txBody>
+          <a:bodyPr/>
+          <a:lstStyle/>
+          <a:p>
+            <a:endParaRPr lang="ko-KR" altLang="en-US"/>
+          </a:p>
+        </p:txBody>
       </p:sp>
       <p:sp>
         <p:nvSpPr>
@@ -21150,6 +22495,13 @@
           </a:solidFill>
           <a:ln/>
         </p:spPr>
+        <p:txBody>
+          <a:bodyPr/>
+          <a:lstStyle/>
+          <a:p>
+            <a:endParaRPr lang="ko-KR" altLang="en-US"/>
+          </a:p>
+        </p:txBody>
       </p:sp>
       <p:sp>
         <p:nvSpPr>
@@ -21170,6 +22522,13 @@
           </a:solidFill>
           <a:ln/>
         </p:spPr>
+        <p:txBody>
+          <a:bodyPr/>
+          <a:lstStyle/>
+          <a:p>
+            <a:endParaRPr lang="ko-KR" altLang="en-US"/>
+          </a:p>
+        </p:txBody>
       </p:sp>
       <p:sp>
         <p:nvSpPr>
@@ -21246,18 +22605,7 @@
                 <a:ea typeface="Courier New" pitchFamily="34" charset="-122"/>
                 <a:cs typeface="Courier New" pitchFamily="34" charset="-120"/>
               </a:rPr>
-              <a:t>$ man </a:t>
-            </a:r>
-            <a:r>
-              <a:rPr lang="en-US" sz="1300" b="1" dirty="0" smtClean="0">
-                <a:solidFill>
-                  <a:srgbClr val="7FE0B0"/>
-                </a:solidFill>
-                <a:latin typeface="Courier New" pitchFamily="34" charset="0"/>
-                <a:ea typeface="Courier New" pitchFamily="34" charset="-122"/>
-                <a:cs typeface="Courier New" pitchFamily="34" charset="-120"/>
-              </a:rPr>
-              <a:t>ls</a:t>
+              <a:t>$ man ls</a:t>
             </a:r>
             <a:endParaRPr lang="en-US" sz="1300" dirty="0"/>
           </a:p>
@@ -21284,6 +22632,13 @@
           </a:solidFill>
           <a:ln/>
         </p:spPr>
+        <p:txBody>
+          <a:bodyPr/>
+          <a:lstStyle/>
+          <a:p>
+            <a:endParaRPr lang="ko-KR" altLang="en-US"/>
+          </a:p>
+        </p:txBody>
       </p:sp>
       <p:sp>
         <p:nvSpPr>
@@ -21304,6 +22659,13 @@
           </a:solidFill>
           <a:ln/>
         </p:spPr>
+        <p:txBody>
+          <a:bodyPr/>
+          <a:lstStyle/>
+          <a:p>
+            <a:endParaRPr lang="ko-KR" altLang="en-US"/>
+          </a:p>
+        </p:txBody>
       </p:sp>
       <p:sp>
         <p:nvSpPr>
@@ -21391,6 +22753,13 @@
             </a:outerShdw>
           </a:effectLst>
         </p:spPr>
+        <p:txBody>
+          <a:bodyPr/>
+          <a:lstStyle/>
+          <a:p>
+            <a:endParaRPr lang="ko-KR" altLang="en-US"/>
+          </a:p>
+        </p:txBody>
       </p:sp>
       <p:sp>
         <p:nvSpPr>
@@ -21457,6 +22826,13 @@
             <a:prstDash val="solid"/>
           </a:ln>
         </p:spPr>
+        <p:txBody>
+          <a:bodyPr/>
+          <a:lstStyle/>
+          <a:p>
+            <a:endParaRPr lang="ko-KR" altLang="en-US"/>
+          </a:p>
+        </p:txBody>
       </p:sp>
       <p:sp>
         <p:nvSpPr>
@@ -21562,6 +22938,13 @@
             <a:prstDash val="solid"/>
           </a:ln>
         </p:spPr>
+        <p:txBody>
+          <a:bodyPr/>
+          <a:lstStyle/>
+          <a:p>
+            <a:endParaRPr lang="ko-KR" altLang="en-US"/>
+          </a:p>
+        </p:txBody>
       </p:sp>
       <p:sp>
         <p:nvSpPr>
@@ -21599,7 +22982,7 @@
               <a:t>f </a:t>
             </a:r>
             <a:r>
-              <a:rPr lang="ko-KR" altLang="en-US" sz="1300" b="1" dirty="0" smtClean="0">
+              <a:rPr lang="ko-KR" altLang="en-US" sz="1300" b="1" dirty="0">
                 <a:solidFill>
                   <a:srgbClr val="F5F7F8"/>
                 </a:solidFill>
@@ -21610,7 +22993,7 @@
               <a:t>혹은</a:t>
             </a:r>
             <a:r>
-              <a:rPr lang="en-US" sz="1300" b="1" dirty="0" smtClean="0">
+              <a:rPr lang="en-US" sz="1300" b="1" dirty="0">
                 <a:solidFill>
                   <a:srgbClr val="F5F7F8"/>
                 </a:solidFill>
@@ -21618,18 +23001,7 @@
                 <a:ea typeface="Courier New" pitchFamily="34" charset="-122"/>
                 <a:cs typeface="Courier New" pitchFamily="34" charset="-120"/>
               </a:rPr>
-              <a:t> </a:t>
-            </a:r>
-            <a:r>
-              <a:rPr lang="en-US" sz="1300" b="1" dirty="0">
-                <a:solidFill>
-                  <a:srgbClr val="F5F7F8"/>
-                </a:solidFill>
-                <a:latin typeface="Courier New" pitchFamily="34" charset="0"/>
-                <a:ea typeface="Courier New" pitchFamily="34" charset="-122"/>
-                <a:cs typeface="Courier New" pitchFamily="34" charset="-120"/>
-              </a:rPr>
-              <a:t>space</a:t>
+              <a:t> space</a:t>
             </a:r>
             <a:endParaRPr lang="en-US" sz="1300" dirty="0"/>
           </a:p>
@@ -21700,6 +23072,13 @@
             <a:prstDash val="solid"/>
           </a:ln>
         </p:spPr>
+        <p:txBody>
+          <a:bodyPr/>
+          <a:lstStyle/>
+          <a:p>
+            <a:endParaRPr lang="ko-KR" altLang="en-US"/>
+          </a:p>
+        </p:txBody>
       </p:sp>
       <p:sp>
         <p:nvSpPr>
@@ -21805,6 +23184,13 @@
             <a:prstDash val="solid"/>
           </a:ln>
         </p:spPr>
+        <p:txBody>
+          <a:bodyPr/>
+          <a:lstStyle/>
+          <a:p>
+            <a:endParaRPr lang="ko-KR" altLang="en-US"/>
+          </a:p>
+        </p:txBody>
       </p:sp>
       <p:sp>
         <p:nvSpPr>
@@ -21938,6 +23324,13 @@
           </a:solidFill>
           <a:ln/>
         </p:spPr>
+        <p:txBody>
+          <a:bodyPr/>
+          <a:lstStyle/>
+          <a:p>
+            <a:endParaRPr lang="ko-KR" altLang="en-US"/>
+          </a:p>
+        </p:txBody>
       </p:sp>
       <p:sp>
         <p:nvSpPr>
@@ -21964,7 +23357,7 @@
               <a:buNone/>
             </a:pPr>
             <a:r>
-              <a:rPr lang="en-US" sz="1300" b="1" dirty="0" smtClean="0">
+              <a:rPr lang="en-US" sz="1300" b="1" dirty="0">
                 <a:solidFill>
                   <a:srgbClr val="1B2028"/>
                 </a:solidFill>
@@ -22155,6 +23548,13 @@
           </a:solidFill>
           <a:ln/>
         </p:spPr>
+        <p:txBody>
+          <a:bodyPr/>
+          <a:lstStyle/>
+          <a:p>
+            <a:endParaRPr lang="ko-KR" altLang="en-US"/>
+          </a:p>
+        </p:txBody>
       </p:sp>
       <p:sp>
         <p:nvSpPr>
@@ -22175,6 +23575,13 @@
           </a:solidFill>
           <a:ln/>
         </p:spPr>
+        <p:txBody>
+          <a:bodyPr/>
+          <a:lstStyle/>
+          <a:p>
+            <a:endParaRPr lang="ko-KR" altLang="en-US"/>
+          </a:p>
+        </p:txBody>
       </p:sp>
       <p:sp>
         <p:nvSpPr>
@@ -22257,6 +23664,13 @@
             </a:outerShdw>
           </a:effectLst>
         </p:spPr>
+        <p:txBody>
+          <a:bodyPr/>
+          <a:lstStyle/>
+          <a:p>
+            <a:endParaRPr lang="ko-KR" altLang="en-US"/>
+          </a:p>
+        </p:txBody>
       </p:sp>
       <p:sp>
         <p:nvSpPr>
@@ -22277,6 +23691,13 @@
           </a:solidFill>
           <a:ln/>
         </p:spPr>
+        <p:txBody>
+          <a:bodyPr/>
+          <a:lstStyle/>
+          <a:p>
+            <a:endParaRPr lang="ko-KR" altLang="en-US"/>
+          </a:p>
+        </p:txBody>
       </p:sp>
       <p:sp>
         <p:nvSpPr>
@@ -22297,6 +23718,13 @@
           </a:solidFill>
           <a:ln/>
         </p:spPr>
+        <p:txBody>
+          <a:bodyPr/>
+          <a:lstStyle/>
+          <a:p>
+            <a:endParaRPr lang="ko-KR" altLang="en-US"/>
+          </a:p>
+        </p:txBody>
       </p:sp>
       <p:sp>
         <p:nvSpPr>
@@ -22317,6 +23745,13 @@
           </a:solidFill>
           <a:ln/>
         </p:spPr>
+        <p:txBody>
+          <a:bodyPr/>
+          <a:lstStyle/>
+          <a:p>
+            <a:endParaRPr lang="ko-KR" altLang="en-US"/>
+          </a:p>
+        </p:txBody>
       </p:sp>
       <p:sp>
         <p:nvSpPr>
@@ -22465,7 +23900,7 @@
               <a:t># root </a:t>
             </a:r>
             <a:r>
-              <a:rPr lang="ko-KR" altLang="en-US" sz="1300" dirty="0" smtClean="0">
+              <a:rPr lang="ko-KR" altLang="en-US" sz="1300" dirty="0">
                 <a:solidFill>
                   <a:srgbClr val="9AA5B1"/>
                 </a:solidFill>
@@ -22476,7 +23911,7 @@
               <a:t>사용자로</a:t>
             </a:r>
             <a:r>
-              <a:rPr lang="en-US" sz="1300" dirty="0" smtClean="0">
+              <a:rPr lang="en-US" sz="1300" dirty="0">
                 <a:solidFill>
                   <a:srgbClr val="9AA5B1"/>
                 </a:solidFill>
@@ -22484,18 +23919,7 @@
                 <a:ea typeface="Courier New" pitchFamily="34" charset="-122"/>
                 <a:cs typeface="Courier New" pitchFamily="34" charset="-120"/>
               </a:rPr>
-              <a:t> </a:t>
-            </a:r>
-            <a:r>
-              <a:rPr lang="en-US" sz="1300" dirty="0">
-                <a:solidFill>
-                  <a:srgbClr val="9AA5B1"/>
-                </a:solidFill>
-                <a:latin typeface="Courier New" pitchFamily="34" charset="0"/>
-                <a:ea typeface="Courier New" pitchFamily="34" charset="-122"/>
-                <a:cs typeface="Courier New" pitchFamily="34" charset="-120"/>
-              </a:rPr>
-              <a:t>전환 (비밀번호 없이 가능)</a:t>
+              <a:t> 전환 (비밀번호 없이 가능)</a:t>
             </a:r>
             <a:endParaRPr lang="en-US" sz="1300" dirty="0"/>
           </a:p>
@@ -22547,6 +23971,13 @@
           </a:solidFill>
           <a:ln/>
         </p:spPr>
+        <p:txBody>
+          <a:bodyPr/>
+          <a:lstStyle/>
+          <a:p>
+            <a:endParaRPr lang="ko-KR" altLang="en-US"/>
+          </a:p>
+        </p:txBody>
       </p:sp>
       <p:sp>
         <p:nvSpPr>
@@ -22573,7 +24004,7 @@
               <a:buNone/>
             </a:pPr>
             <a:r>
-              <a:rPr lang="en-US" sz="1300" b="1" dirty="0" smtClean="0">
+              <a:rPr lang="en-US" sz="1300" b="1" dirty="0">
                 <a:solidFill>
                   <a:srgbClr val="1B2028"/>
                 </a:solidFill>
@@ -22762,6 +24193,13 @@
           </a:solidFill>
           <a:ln/>
         </p:spPr>
+        <p:txBody>
+          <a:bodyPr/>
+          <a:lstStyle/>
+          <a:p>
+            <a:endParaRPr lang="ko-KR" altLang="en-US"/>
+          </a:p>
+        </p:txBody>
       </p:sp>
       <p:sp>
         <p:nvSpPr>
@@ -22902,6 +24340,13 @@
           </a:solidFill>
           <a:ln/>
         </p:spPr>
+        <p:txBody>
+          <a:bodyPr/>
+          <a:lstStyle/>
+          <a:p>
+            <a:endParaRPr lang="ko-KR" altLang="en-US"/>
+          </a:p>
+        </p:txBody>
       </p:sp>
       <p:sp>
         <p:nvSpPr>
@@ -23042,6 +24487,13 @@
           </a:solidFill>
           <a:ln/>
         </p:spPr>
+        <p:txBody>
+          <a:bodyPr/>
+          <a:lstStyle/>
+          <a:p>
+            <a:endParaRPr lang="ko-KR" altLang="en-US"/>
+          </a:p>
+        </p:txBody>
       </p:sp>
       <p:sp>
         <p:nvSpPr>
@@ -23189,6 +24641,13 @@
             <a:prstDash val="solid"/>
           </a:ln>
         </p:spPr>
+        <p:txBody>
+          <a:bodyPr/>
+          <a:lstStyle/>
+          <a:p>
+            <a:endParaRPr lang="ko-KR" altLang="en-US"/>
+          </a:p>
+        </p:txBody>
       </p:sp>
       <p:sp>
         <p:nvSpPr>
@@ -23215,7 +24674,7 @@
               <a:buNone/>
             </a:pPr>
             <a:r>
-              <a:rPr lang="en-US" sz="1300" b="1" dirty="0" smtClean="0">
+              <a:rPr lang="en-US" sz="1300" b="1" dirty="0">
                 <a:solidFill>
                   <a:srgbClr val="9AA5B1"/>
                 </a:solidFill>
@@ -23255,6 +24714,13 @@
             <a:prstDash val="solid"/>
           </a:ln>
         </p:spPr>
+        <p:txBody>
+          <a:bodyPr/>
+          <a:lstStyle/>
+          <a:p>
+            <a:endParaRPr lang="ko-KR" altLang="en-US"/>
+          </a:p>
+        </p:txBody>
       </p:sp>
       <p:sp>
         <p:nvSpPr>
@@ -23321,6 +24787,13 @@
             <a:prstDash val="solid"/>
           </a:ln>
         </p:spPr>
+        <p:txBody>
+          <a:bodyPr/>
+          <a:lstStyle/>
+          <a:p>
+            <a:endParaRPr lang="ko-KR" altLang="en-US"/>
+          </a:p>
+        </p:txBody>
       </p:sp>
       <p:sp>
         <p:nvSpPr>
@@ -23384,6 +24857,13 @@
             <a:tailEnd type="triangle"/>
           </a:ln>
         </p:spPr>
+        <p:txBody>
+          <a:bodyPr/>
+          <a:lstStyle/>
+          <a:p>
+            <a:endParaRPr lang="ko-KR" altLang="en-US"/>
+          </a:p>
+        </p:txBody>
       </p:sp>
       <p:sp>
         <p:nvSpPr>
@@ -23408,6 +24888,13 @@
             <a:tailEnd type="triangle"/>
           </a:ln>
         </p:spPr>
+        <p:txBody>
+          <a:bodyPr/>
+          <a:lstStyle/>
+          <a:p>
+            <a:endParaRPr lang="ko-KR" altLang="en-US"/>
+          </a:p>
+        </p:txBody>
       </p:sp>
       <p:sp>
         <p:nvSpPr>
@@ -23432,6 +24919,13 @@
             <a:tailEnd type="triangle"/>
           </a:ln>
         </p:spPr>
+        <p:txBody>
+          <a:bodyPr/>
+          <a:lstStyle/>
+          <a:p>
+            <a:endParaRPr lang="ko-KR" altLang="en-US"/>
+          </a:p>
+        </p:txBody>
       </p:sp>
       <p:sp>
         <p:nvSpPr>
@@ -23452,6 +24946,13 @@
           </a:solidFill>
           <a:ln/>
         </p:spPr>
+        <p:txBody>
+          <a:bodyPr/>
+          <a:lstStyle/>
+          <a:p>
+            <a:endParaRPr lang="ko-KR" altLang="en-US"/>
+          </a:p>
+        </p:txBody>
       </p:sp>
       <p:sp>
         <p:nvSpPr>
@@ -24015,6 +25516,13 @@
             </a:outerShdw>
           </a:effectLst>
         </p:spPr>
+        <p:txBody>
+          <a:bodyPr/>
+          <a:lstStyle/>
+          <a:p>
+            <a:endParaRPr lang="ko-KR" altLang="en-US"/>
+          </a:p>
+        </p:txBody>
       </p:sp>
       <p:sp>
         <p:nvSpPr>
@@ -24035,6 +25543,13 @@
           </a:solidFill>
           <a:ln/>
         </p:spPr>
+        <p:txBody>
+          <a:bodyPr/>
+          <a:lstStyle/>
+          <a:p>
+            <a:endParaRPr lang="ko-KR" altLang="en-US"/>
+          </a:p>
+        </p:txBody>
       </p:sp>
       <p:sp>
         <p:nvSpPr>
@@ -24055,6 +25570,13 @@
           </a:solidFill>
           <a:ln/>
         </p:spPr>
+        <p:txBody>
+          <a:bodyPr/>
+          <a:lstStyle/>
+          <a:p>
+            <a:endParaRPr lang="ko-KR" altLang="en-US"/>
+          </a:p>
+        </p:txBody>
       </p:sp>
       <p:sp>
         <p:nvSpPr>
@@ -24075,6 +25597,13 @@
           </a:solidFill>
           <a:ln/>
         </p:spPr>
+        <p:txBody>
+          <a:bodyPr/>
+          <a:lstStyle/>
+          <a:p>
+            <a:endParaRPr lang="ko-KR" altLang="en-US"/>
+          </a:p>
+        </p:txBody>
       </p:sp>
       <p:sp>
         <p:nvSpPr>
@@ -24453,6 +25982,13 @@
             </a:outerShdw>
           </a:effectLst>
         </p:spPr>
+        <p:txBody>
+          <a:bodyPr/>
+          <a:lstStyle/>
+          <a:p>
+            <a:endParaRPr lang="ko-KR" altLang="en-US"/>
+          </a:p>
+        </p:txBody>
       </p:sp>
       <p:sp>
         <p:nvSpPr>
@@ -24473,6 +26009,13 @@
           </a:solidFill>
           <a:ln/>
         </p:spPr>
+        <p:txBody>
+          <a:bodyPr/>
+          <a:lstStyle/>
+          <a:p>
+            <a:endParaRPr lang="ko-KR" altLang="en-US"/>
+          </a:p>
+        </p:txBody>
       </p:sp>
       <p:sp>
         <p:nvSpPr>
@@ -24493,6 +26036,13 @@
           </a:solidFill>
           <a:ln/>
         </p:spPr>
+        <p:txBody>
+          <a:bodyPr/>
+          <a:lstStyle/>
+          <a:p>
+            <a:endParaRPr lang="ko-KR" altLang="en-US"/>
+          </a:p>
+        </p:txBody>
       </p:sp>
       <p:sp>
         <p:nvSpPr>
@@ -24513,6 +26063,13 @@
           </a:solidFill>
           <a:ln/>
         </p:spPr>
+        <p:txBody>
+          <a:bodyPr/>
+          <a:lstStyle/>
+          <a:p>
+            <a:endParaRPr lang="ko-KR" altLang="en-US"/>
+          </a:p>
+        </p:txBody>
       </p:sp>
       <p:sp>
         <p:nvSpPr>
@@ -24643,6 +26200,13 @@
             </a:outerShdw>
           </a:effectLst>
         </p:spPr>
+        <p:txBody>
+          <a:bodyPr/>
+          <a:lstStyle/>
+          <a:p>
+            <a:endParaRPr lang="ko-KR" altLang="en-US"/>
+          </a:p>
+        </p:txBody>
       </p:sp>
       <p:sp>
         <p:nvSpPr>
@@ -24663,6 +26227,13 @@
           </a:solidFill>
           <a:ln/>
         </p:spPr>
+        <p:txBody>
+          <a:bodyPr/>
+          <a:lstStyle/>
+          <a:p>
+            <a:endParaRPr lang="ko-KR" altLang="en-US"/>
+          </a:p>
+        </p:txBody>
       </p:sp>
       <p:sp>
         <p:nvSpPr>
@@ -24683,6 +26254,13 @@
           </a:solidFill>
           <a:ln/>
         </p:spPr>
+        <p:txBody>
+          <a:bodyPr/>
+          <a:lstStyle/>
+          <a:p>
+            <a:endParaRPr lang="ko-KR" altLang="en-US"/>
+          </a:p>
+        </p:txBody>
       </p:sp>
       <p:sp>
         <p:nvSpPr>
@@ -24703,6 +26281,13 @@
           </a:solidFill>
           <a:ln/>
         </p:spPr>
+        <p:txBody>
+          <a:bodyPr/>
+          <a:lstStyle/>
+          <a:p>
+            <a:endParaRPr lang="ko-KR" altLang="en-US"/>
+          </a:p>
+        </p:txBody>
       </p:sp>
       <p:sp>
         <p:nvSpPr>
@@ -24879,6 +26464,13 @@
           </a:solidFill>
           <a:ln/>
         </p:spPr>
+        <p:txBody>
+          <a:bodyPr/>
+          <a:lstStyle/>
+          <a:p>
+            <a:endParaRPr lang="ko-KR" altLang="en-US"/>
+          </a:p>
+        </p:txBody>
       </p:sp>
       <p:sp>
         <p:nvSpPr>
@@ -24905,7 +26497,7 @@
               <a:buNone/>
             </a:pPr>
             <a:r>
-              <a:rPr lang="en-US" sz="1300" b="1" dirty="0" smtClean="0">
+              <a:rPr lang="en-US" sz="1300" b="1" dirty="0">
                 <a:solidFill>
                   <a:srgbClr val="1B2028"/>
                 </a:solidFill>
@@ -25064,6 +26656,13 @@
             </a:outerShdw>
           </a:effectLst>
         </p:spPr>
+        <p:txBody>
+          <a:bodyPr/>
+          <a:lstStyle/>
+          <a:p>
+            <a:endParaRPr lang="ko-KR" altLang="en-US"/>
+          </a:p>
+        </p:txBody>
       </p:sp>
       <p:sp>
         <p:nvSpPr>
@@ -25084,6 +26683,13 @@
           </a:solidFill>
           <a:ln/>
         </p:spPr>
+        <p:txBody>
+          <a:bodyPr/>
+          <a:lstStyle/>
+          <a:p>
+            <a:endParaRPr lang="ko-KR" altLang="en-US"/>
+          </a:p>
+        </p:txBody>
       </p:sp>
       <p:sp>
         <p:nvSpPr>
@@ -25104,6 +26710,13 @@
           </a:solidFill>
           <a:ln/>
         </p:spPr>
+        <p:txBody>
+          <a:bodyPr/>
+          <a:lstStyle/>
+          <a:p>
+            <a:endParaRPr lang="ko-KR" altLang="en-US"/>
+          </a:p>
+        </p:txBody>
       </p:sp>
       <p:sp>
         <p:nvSpPr>
@@ -25124,6 +26737,13 @@
           </a:solidFill>
           <a:ln/>
         </p:spPr>
+        <p:txBody>
+          <a:bodyPr/>
+          <a:lstStyle/>
+          <a:p>
+            <a:endParaRPr lang="ko-KR" altLang="en-US"/>
+          </a:p>
+        </p:txBody>
       </p:sp>
       <p:sp>
         <p:nvSpPr>
@@ -27222,6 +28842,13 @@
             </a:outerShdw>
           </a:effectLst>
         </p:spPr>
+        <p:txBody>
+          <a:bodyPr/>
+          <a:lstStyle/>
+          <a:p>
+            <a:endParaRPr lang="ko-KR" altLang="en-US"/>
+          </a:p>
+        </p:txBody>
       </p:sp>
       <p:sp>
         <p:nvSpPr>
@@ -27242,6 +28869,13 @@
           </a:solidFill>
           <a:ln/>
         </p:spPr>
+        <p:txBody>
+          <a:bodyPr/>
+          <a:lstStyle/>
+          <a:p>
+            <a:endParaRPr lang="ko-KR" altLang="en-US"/>
+          </a:p>
+        </p:txBody>
       </p:sp>
       <p:sp>
         <p:nvSpPr>
@@ -27262,6 +28896,13 @@
           </a:solidFill>
           <a:ln/>
         </p:spPr>
+        <p:txBody>
+          <a:bodyPr/>
+          <a:lstStyle/>
+          <a:p>
+            <a:endParaRPr lang="ko-KR" altLang="en-US"/>
+          </a:p>
+        </p:txBody>
       </p:sp>
       <p:sp>
         <p:nvSpPr>
@@ -27282,6 +28923,13 @@
           </a:solidFill>
           <a:ln/>
         </p:spPr>
+        <p:txBody>
+          <a:bodyPr/>
+          <a:lstStyle/>
+          <a:p>
+            <a:endParaRPr lang="ko-KR" altLang="en-US"/>
+          </a:p>
+        </p:txBody>
       </p:sp>
       <p:sp>
         <p:nvSpPr>

</xml_diff>